<commit_message>
Finishing the flagged data!
</commit_message>
<xml_diff>
--- a/images/Flagged Data Graphics.pptx
+++ b/images/Flagged Data Graphics.pptx
@@ -4,12 +4,16 @@
   <p:sldMasterIdLst>
     <p:sldMasterId id="2147483648" r:id="rId1"/>
   </p:sldMasterIdLst>
+  <p:notesMasterIdLst>
+    <p:notesMasterId r:id="rId8"/>
+  </p:notesMasterIdLst>
   <p:sldIdLst>
     <p:sldId id="256" r:id="rId2"/>
-    <p:sldId id="257" r:id="rId3"/>
-    <p:sldId id="258" r:id="rId4"/>
-    <p:sldId id="259" r:id="rId5"/>
-    <p:sldId id="260" r:id="rId6"/>
+    <p:sldId id="269" r:id="rId3"/>
+    <p:sldId id="268" r:id="rId4"/>
+    <p:sldId id="267" r:id="rId5"/>
+    <p:sldId id="257" r:id="rId6"/>
+    <p:sldId id="270" r:id="rId7"/>
   </p:sldIdLst>
   <p:sldSz cx="12192000" cy="6858000"/>
   <p:notesSz cx="6858000" cy="9144000"/>
@@ -119,7 +123,7 @@
 <file path=ppt/revisionInfo.xml><?xml version="1.0" encoding="utf-8"?>
 <p1510:revInfo xmlns:a="http://schemas.openxmlformats.org/drawingml/2006/main" xmlns:r="http://schemas.openxmlformats.org/officeDocument/2006/relationships" xmlns:p1510="http://schemas.microsoft.com/office/powerpoint/2015/10/main">
   <p1510:revLst>
-    <p1510:client id="{E4223B4E-FD89-4A6E-9E8C-49204390B3F5}" v="1" dt="2026-07-23T13:34:59.391"/>
+    <p1510:client id="{E4223B4E-FD89-4A6E-9E8C-49204390B3F5}" v="9" dt="2026-07-24T22:33:57.840"/>
   </p1510:revLst>
 </p1510:revInfo>
 </file>
@@ -128,29 +132,859 @@
 <pc:chgInfo xmlns:a="http://schemas.openxmlformats.org/drawingml/2006/main" xmlns:r="http://schemas.openxmlformats.org/officeDocument/2006/relationships" xmlns:ac="http://schemas.microsoft.com/office/drawing/2013/main/command" xmlns:pc="http://schemas.microsoft.com/office/powerpoint/2013/main/command">
   <pc:docChgLst>
     <pc:chgData name="Savannah Karin Miller" userId="22c948fc-cece-4b89-9db3-f9f8a6b29aef" providerId="ADAL" clId="{39DE2C0E-7095-495B-81F3-37AFAFAFC50B}"/>
-    <pc:docChg chg="modSld">
-      <pc:chgData name="Savannah Karin Miller" userId="22c948fc-cece-4b89-9db3-f9f8a6b29aef" providerId="ADAL" clId="{39DE2C0E-7095-495B-81F3-37AFAFAFC50B}" dt="2026-07-23T13:34:59.388" v="0"/>
+    <pc:docChg chg="undo custSel addSld delSld modSld sldOrd">
+      <pc:chgData name="Savannah Karin Miller" userId="22c948fc-cece-4b89-9db3-f9f8a6b29aef" providerId="ADAL" clId="{39DE2C0E-7095-495B-81F3-37AFAFAFC50B}" dt="2026-07-24T23:42:49.573" v="440" actId="20577"/>
       <pc:docMkLst>
         <pc:docMk/>
       </pc:docMkLst>
-      <pc:sldChg chg="modSp">
-        <pc:chgData name="Savannah Karin Miller" userId="22c948fc-cece-4b89-9db3-f9f8a6b29aef" providerId="ADAL" clId="{39DE2C0E-7095-495B-81F3-37AFAFAFC50B}" dt="2026-07-23T13:34:59.388" v="0"/>
+      <pc:sldChg chg="addSp delSp modSp mod setBg modNotesTx">
+        <pc:chgData name="Savannah Karin Miller" userId="22c948fc-cece-4b89-9db3-f9f8a6b29aef" providerId="ADAL" clId="{39DE2C0E-7095-495B-81F3-37AFAFAFC50B}" dt="2026-07-24T23:42:49.573" v="440" actId="20577"/>
+        <pc:sldMkLst>
+          <pc:docMk/>
+          <pc:sldMk cId="4186647946" sldId="257"/>
+        </pc:sldMkLst>
+        <pc:spChg chg="add del mod">
+          <ac:chgData name="Savannah Karin Miller" userId="22c948fc-cece-4b89-9db3-f9f8a6b29aef" providerId="ADAL" clId="{39DE2C0E-7095-495B-81F3-37AFAFAFC50B}" dt="2026-07-24T22:26:55.451" v="258" actId="1076"/>
+          <ac:spMkLst>
+            <pc:docMk/>
+            <pc:sldMk cId="4186647946" sldId="257"/>
+            <ac:spMk id="2" creationId="{695C182A-678A-6134-65A2-0E938BE8159D}"/>
+          </ac:spMkLst>
+        </pc:spChg>
+        <pc:spChg chg="del mod">
+          <ac:chgData name="Savannah Karin Miller" userId="22c948fc-cece-4b89-9db3-f9f8a6b29aef" providerId="ADAL" clId="{39DE2C0E-7095-495B-81F3-37AFAFAFC50B}" dt="2026-07-24T08:29:55.378" v="4" actId="478"/>
+          <ac:spMkLst>
+            <pc:docMk/>
+            <pc:sldMk cId="4186647946" sldId="257"/>
+            <ac:spMk id="3" creationId="{B7594FA6-6FF4-3761-215A-ADE5662B2B3A}"/>
+          </ac:spMkLst>
+        </pc:spChg>
+        <pc:spChg chg="add del mod">
+          <ac:chgData name="Savannah Karin Miller" userId="22c948fc-cece-4b89-9db3-f9f8a6b29aef" providerId="ADAL" clId="{39DE2C0E-7095-495B-81F3-37AFAFAFC50B}" dt="2026-07-24T08:30:04.155" v="8" actId="478"/>
+          <ac:spMkLst>
+            <pc:docMk/>
+            <pc:sldMk cId="4186647946" sldId="257"/>
+            <ac:spMk id="5" creationId="{D7B3E15E-A4CE-3D60-65B5-E0AA2B539C8D}"/>
+          </ac:spMkLst>
+        </pc:spChg>
+        <pc:spChg chg="add del mod">
+          <ac:chgData name="Savannah Karin Miller" userId="22c948fc-cece-4b89-9db3-f9f8a6b29aef" providerId="ADAL" clId="{39DE2C0E-7095-495B-81F3-37AFAFAFC50B}" dt="2026-07-24T08:31:18.339" v="12" actId="478"/>
+          <ac:spMkLst>
+            <pc:docMk/>
+            <pc:sldMk cId="4186647946" sldId="257"/>
+            <ac:spMk id="9" creationId="{8B81A7D8-A7BC-7A75-E131-DC91EE0FD22D}"/>
+          </ac:spMkLst>
+        </pc:spChg>
+        <pc:spChg chg="add del">
+          <ac:chgData name="Savannah Karin Miller" userId="22c948fc-cece-4b89-9db3-f9f8a6b29aef" providerId="ADAL" clId="{39DE2C0E-7095-495B-81F3-37AFAFAFC50B}" dt="2026-07-24T08:31:18.941" v="13" actId="26606"/>
+          <ac:spMkLst>
+            <pc:docMk/>
+            <pc:sldMk cId="4186647946" sldId="257"/>
+            <ac:spMk id="12" creationId="{D4771268-CB57-404A-9271-370EB28F6090}"/>
+          </ac:spMkLst>
+        </pc:spChg>
+        <pc:graphicFrameChg chg="add mod modGraphic">
+          <ac:chgData name="Savannah Karin Miller" userId="22c948fc-cece-4b89-9db3-f9f8a6b29aef" providerId="ADAL" clId="{39DE2C0E-7095-495B-81F3-37AFAFAFC50B}" dt="2026-07-24T22:27:05.494" v="260" actId="14100"/>
+          <ac:graphicFrameMkLst>
+            <pc:docMk/>
+            <pc:sldMk cId="4186647946" sldId="257"/>
+            <ac:graphicFrameMk id="13" creationId="{A8AA364A-5A65-A4AA-B115-25B477A5BC15}"/>
+          </ac:graphicFrameMkLst>
+        </pc:graphicFrameChg>
+        <pc:picChg chg="add del mod">
+          <ac:chgData name="Savannah Karin Miller" userId="22c948fc-cece-4b89-9db3-f9f8a6b29aef" providerId="ADAL" clId="{39DE2C0E-7095-495B-81F3-37AFAFAFC50B}" dt="2026-07-24T22:23:26.052" v="213" actId="21"/>
+          <ac:picMkLst>
+            <pc:docMk/>
+            <pc:sldMk cId="4186647946" sldId="257"/>
+            <ac:picMk id="7" creationId="{FAA09751-CDC5-F023-1D5D-91B2E91E8801}"/>
+          </ac:picMkLst>
+        </pc:picChg>
+        <pc:picChg chg="add del mod">
+          <ac:chgData name="Savannah Karin Miller" userId="22c948fc-cece-4b89-9db3-f9f8a6b29aef" providerId="ADAL" clId="{39DE2C0E-7095-495B-81F3-37AFAFAFC50B}" dt="2026-07-24T22:22:14.146" v="202" actId="21"/>
+          <ac:picMkLst>
+            <pc:docMk/>
+            <pc:sldMk cId="4186647946" sldId="257"/>
+            <ac:picMk id="11" creationId="{6A441143-1755-F230-5FEC-5D4EE4844DF8}"/>
+          </ac:picMkLst>
+        </pc:picChg>
+        <pc:picChg chg="add del">
+          <ac:chgData name="Savannah Karin Miller" userId="22c948fc-cece-4b89-9db3-f9f8a6b29aef" providerId="ADAL" clId="{39DE2C0E-7095-495B-81F3-37AFAFAFC50B}" dt="2026-07-24T22:22:18.544" v="204" actId="21"/>
+          <ac:picMkLst>
+            <pc:docMk/>
+            <pc:sldMk cId="4186647946" sldId="257"/>
+            <ac:picMk id="15" creationId="{6004E20E-356D-D1E2-B1D0-BDE3FC057FDA}"/>
+          </ac:picMkLst>
+        </pc:picChg>
+      </pc:sldChg>
+      <pc:sldChg chg="addSp delSp modSp del mod">
+        <pc:chgData name="Savannah Karin Miller" userId="22c948fc-cece-4b89-9db3-f9f8a6b29aef" providerId="ADAL" clId="{39DE2C0E-7095-495B-81F3-37AFAFAFC50B}" dt="2026-07-24T22:30:12.811" v="337" actId="2696"/>
+        <pc:sldMkLst>
+          <pc:docMk/>
+          <pc:sldMk cId="2631489723" sldId="258"/>
+        </pc:sldMkLst>
+        <pc:spChg chg="del">
+          <ac:chgData name="Savannah Karin Miller" userId="22c948fc-cece-4b89-9db3-f9f8a6b29aef" providerId="ADAL" clId="{39DE2C0E-7095-495B-81F3-37AFAFAFC50B}" dt="2026-07-24T08:32:57.254" v="37" actId="478"/>
+          <ac:spMkLst>
+            <pc:docMk/>
+            <pc:sldMk cId="2631489723" sldId="258"/>
+            <ac:spMk id="3" creationId="{C2C3EA00-06DD-DF86-26AE-43C89419A4E7}"/>
+          </ac:spMkLst>
+        </pc:spChg>
+        <pc:picChg chg="add del mod">
+          <ac:chgData name="Savannah Karin Miller" userId="22c948fc-cece-4b89-9db3-f9f8a6b29aef" providerId="ADAL" clId="{39DE2C0E-7095-495B-81F3-37AFAFAFC50B}" dt="2026-07-24T22:28:08.242" v="296" actId="21"/>
+          <ac:picMkLst>
+            <pc:docMk/>
+            <pc:sldMk cId="2631489723" sldId="258"/>
+            <ac:picMk id="5" creationId="{E6038268-15C3-2528-9867-A89D08F0134D}"/>
+          </ac:picMkLst>
+        </pc:picChg>
+        <pc:picChg chg="add del mod">
+          <ac:chgData name="Savannah Karin Miller" userId="22c948fc-cece-4b89-9db3-f9f8a6b29aef" providerId="ADAL" clId="{39DE2C0E-7095-495B-81F3-37AFAFAFC50B}" dt="2026-07-24T22:22:54.567" v="208" actId="21"/>
+          <ac:picMkLst>
+            <pc:docMk/>
+            <pc:sldMk cId="2631489723" sldId="258"/>
+            <ac:picMk id="7" creationId="{7F035AA2-0941-E76C-E8D1-FEE8D6539CE0}"/>
+          </ac:picMkLst>
+        </pc:picChg>
+      </pc:sldChg>
+      <pc:sldChg chg="del">
+        <pc:chgData name="Savannah Karin Miller" userId="22c948fc-cece-4b89-9db3-f9f8a6b29aef" providerId="ADAL" clId="{39DE2C0E-7095-495B-81F3-37AFAFAFC50B}" dt="2026-07-24T22:30:17.035" v="339" actId="2696"/>
+        <pc:sldMkLst>
+          <pc:docMk/>
+          <pc:sldMk cId="1853752826" sldId="259"/>
+        </pc:sldMkLst>
+      </pc:sldChg>
+      <pc:sldChg chg="addSp delSp modSp del mod">
+        <pc:chgData name="Savannah Karin Miller" userId="22c948fc-cece-4b89-9db3-f9f8a6b29aef" providerId="ADAL" clId="{39DE2C0E-7095-495B-81F3-37AFAFAFC50B}" dt="2026-07-24T22:30:21.098" v="341" actId="2696"/>
         <pc:sldMkLst>
           <pc:docMk/>
           <pc:sldMk cId="4083801371" sldId="260"/>
         </pc:sldMkLst>
-        <pc:spChg chg="mod">
-          <ac:chgData name="Savannah Karin Miller" userId="22c948fc-cece-4b89-9db3-f9f8a6b29aef" providerId="ADAL" clId="{39DE2C0E-7095-495B-81F3-37AFAFAFC50B}" dt="2026-07-23T13:34:59.388" v="0"/>
+        <pc:spChg chg="del mod">
+          <ac:chgData name="Savannah Karin Miller" userId="22c948fc-cece-4b89-9db3-f9f8a6b29aef" providerId="ADAL" clId="{39DE2C0E-7095-495B-81F3-37AFAFAFC50B}" dt="2026-07-24T08:20:54.198" v="1" actId="931"/>
           <ac:spMkLst>
             <pc:docMk/>
             <pc:sldMk cId="4083801371" sldId="260"/>
             <ac:spMk id="3" creationId="{E4F5D803-F367-5D18-11BD-A94E3442D25A}"/>
           </ac:spMkLst>
         </pc:spChg>
+        <pc:spChg chg="add mod">
+          <ac:chgData name="Savannah Karin Miller" userId="22c948fc-cece-4b89-9db3-f9f8a6b29aef" providerId="ADAL" clId="{39DE2C0E-7095-495B-81F3-37AFAFAFC50B}" dt="2026-07-24T22:28:26.331" v="298" actId="21"/>
+          <ac:spMkLst>
+            <pc:docMk/>
+            <pc:sldMk cId="4083801371" sldId="260"/>
+            <ac:spMk id="7" creationId="{4BF5096C-A90B-CA93-1631-52A698418B1F}"/>
+          </ac:spMkLst>
+        </pc:spChg>
+        <pc:picChg chg="add del mod ord">
+          <ac:chgData name="Savannah Karin Miller" userId="22c948fc-cece-4b89-9db3-f9f8a6b29aef" providerId="ADAL" clId="{39DE2C0E-7095-495B-81F3-37AFAFAFC50B}" dt="2026-07-24T22:28:26.331" v="298" actId="21"/>
+          <ac:picMkLst>
+            <pc:docMk/>
+            <pc:sldMk cId="4083801371" sldId="260"/>
+            <ac:picMk id="5" creationId="{236AC3D8-2D8B-98AF-86EF-2722909489E7}"/>
+          </ac:picMkLst>
+        </pc:picChg>
+      </pc:sldChg>
+      <pc:sldChg chg="addSp delSp modSp new del mod">
+        <pc:chgData name="Savannah Karin Miller" userId="22c948fc-cece-4b89-9db3-f9f8a6b29aef" providerId="ADAL" clId="{39DE2C0E-7095-495B-81F3-37AFAFAFC50B}" dt="2026-07-24T22:30:10.628" v="336" actId="2696"/>
+        <pc:sldMkLst>
+          <pc:docMk/>
+          <pc:sldMk cId="1894582898" sldId="261"/>
+        </pc:sldMkLst>
+        <pc:spChg chg="mod">
+          <ac:chgData name="Savannah Karin Miller" userId="22c948fc-cece-4b89-9db3-f9f8a6b29aef" providerId="ADAL" clId="{39DE2C0E-7095-495B-81F3-37AFAFAFC50B}" dt="2026-07-24T08:32:25.450" v="36" actId="20577"/>
+          <ac:spMkLst>
+            <pc:docMk/>
+            <pc:sldMk cId="1894582898" sldId="261"/>
+            <ac:spMk id="2" creationId="{C621FCAA-4868-EBCE-02A2-582263F0A7DD}"/>
+          </ac:spMkLst>
+        </pc:spChg>
+        <pc:spChg chg="del">
+          <ac:chgData name="Savannah Karin Miller" userId="22c948fc-cece-4b89-9db3-f9f8a6b29aef" providerId="ADAL" clId="{39DE2C0E-7095-495B-81F3-37AFAFAFC50B}" dt="2026-07-24T08:32:20.852" v="21" actId="22"/>
+          <ac:spMkLst>
+            <pc:docMk/>
+            <pc:sldMk cId="1894582898" sldId="261"/>
+            <ac:spMk id="3" creationId="{C55F419F-A208-CF45-0E8C-606027A5F929}"/>
+          </ac:spMkLst>
+        </pc:spChg>
+        <pc:spChg chg="add mod">
+          <ac:chgData name="Savannah Karin Miller" userId="22c948fc-cece-4b89-9db3-f9f8a6b29aef" providerId="ADAL" clId="{39DE2C0E-7095-495B-81F3-37AFAFAFC50B}" dt="2026-07-24T22:29:38.629" v="329" actId="21"/>
+          <ac:spMkLst>
+            <pc:docMk/>
+            <pc:sldMk cId="1894582898" sldId="261"/>
+            <ac:spMk id="9" creationId="{8DC9C6D1-7572-7894-BB66-1343C7D16AC6}"/>
+          </ac:spMkLst>
+        </pc:spChg>
+        <pc:picChg chg="add del mod ord">
+          <ac:chgData name="Savannah Karin Miller" userId="22c948fc-cece-4b89-9db3-f9f8a6b29aef" providerId="ADAL" clId="{39DE2C0E-7095-495B-81F3-37AFAFAFC50B}" dt="2026-07-24T22:29:38.629" v="329" actId="21"/>
+          <ac:picMkLst>
+            <pc:docMk/>
+            <pc:sldMk cId="1894582898" sldId="261"/>
+            <ac:picMk id="5" creationId="{66014150-F558-E5B1-7E4E-A5FE3B5545C8}"/>
+          </ac:picMkLst>
+        </pc:picChg>
+        <pc:picChg chg="add del mod">
+          <ac:chgData name="Savannah Karin Miller" userId="22c948fc-cece-4b89-9db3-f9f8a6b29aef" providerId="ADAL" clId="{39DE2C0E-7095-495B-81F3-37AFAFAFC50B}" dt="2026-07-24T22:29:21.486" v="327" actId="21"/>
+          <ac:picMkLst>
+            <pc:docMk/>
+            <pc:sldMk cId="1894582898" sldId="261"/>
+            <ac:picMk id="7" creationId="{170806BC-BF82-A000-B4DF-74CEA0357FC2}"/>
+          </ac:picMkLst>
+        </pc:picChg>
+      </pc:sldChg>
+      <pc:sldChg chg="addSp delSp modSp new del mod">
+        <pc:chgData name="Savannah Karin Miller" userId="22c948fc-cece-4b89-9db3-f9f8a6b29aef" providerId="ADAL" clId="{39DE2C0E-7095-495B-81F3-37AFAFAFC50B}" dt="2026-07-24T22:30:14.864" v="338" actId="2696"/>
+        <pc:sldMkLst>
+          <pc:docMk/>
+          <pc:sldMk cId="174794945" sldId="262"/>
+        </pc:sldMkLst>
+        <pc:spChg chg="mod">
+          <ac:chgData name="Savannah Karin Miller" userId="22c948fc-cece-4b89-9db3-f9f8a6b29aef" providerId="ADAL" clId="{39DE2C0E-7095-495B-81F3-37AFAFAFC50B}" dt="2026-07-24T08:34:33.546" v="59" actId="20577"/>
+          <ac:spMkLst>
+            <pc:docMk/>
+            <pc:sldMk cId="174794945" sldId="262"/>
+            <ac:spMk id="2" creationId="{07E95C71-A163-13B3-5F20-61AACB8FE5B4}"/>
+          </ac:spMkLst>
+        </pc:spChg>
+        <pc:spChg chg="del">
+          <ac:chgData name="Savannah Karin Miller" userId="22c948fc-cece-4b89-9db3-f9f8a6b29aef" providerId="ADAL" clId="{39DE2C0E-7095-495B-81F3-37AFAFAFC50B}" dt="2026-07-24T08:34:36.335" v="60" actId="478"/>
+          <ac:spMkLst>
+            <pc:docMk/>
+            <pc:sldMk cId="174794945" sldId="262"/>
+            <ac:spMk id="3" creationId="{29499296-5035-3606-5AE2-AF702D216AC3}"/>
+          </ac:spMkLst>
+        </pc:spChg>
+        <pc:picChg chg="add del mod">
+          <ac:chgData name="Savannah Karin Miller" userId="22c948fc-cece-4b89-9db3-f9f8a6b29aef" providerId="ADAL" clId="{39DE2C0E-7095-495B-81F3-37AFAFAFC50B}" dt="2026-07-24T22:29:58.366" v="333" actId="21"/>
+          <ac:picMkLst>
+            <pc:docMk/>
+            <pc:sldMk cId="174794945" sldId="262"/>
+            <ac:picMk id="5" creationId="{A14EC5E3-39FC-E78B-B111-59AE6AE02FE9}"/>
+          </ac:picMkLst>
+        </pc:picChg>
+        <pc:picChg chg="add del mod">
+          <ac:chgData name="Savannah Karin Miller" userId="22c948fc-cece-4b89-9db3-f9f8a6b29aef" providerId="ADAL" clId="{39DE2C0E-7095-495B-81F3-37AFAFAFC50B}" dt="2026-07-24T22:29:45.270" v="331" actId="21"/>
+          <ac:picMkLst>
+            <pc:docMk/>
+            <pc:sldMk cId="174794945" sldId="262"/>
+            <ac:picMk id="7" creationId="{5BB55A70-1C9E-1D3F-8B95-7D96EFC01AE6}"/>
+          </ac:picMkLst>
+        </pc:picChg>
+      </pc:sldChg>
+      <pc:sldChg chg="modSp new del mod">
+        <pc:chgData name="Savannah Karin Miller" userId="22c948fc-cece-4b89-9db3-f9f8a6b29aef" providerId="ADAL" clId="{39DE2C0E-7095-495B-81F3-37AFAFAFC50B}" dt="2026-07-24T22:30:23.084" v="342" actId="2696"/>
+        <pc:sldMkLst>
+          <pc:docMk/>
+          <pc:sldMk cId="649949001" sldId="263"/>
+        </pc:sldMkLst>
+        <pc:spChg chg="mod">
+          <ac:chgData name="Savannah Karin Miller" userId="22c948fc-cece-4b89-9db3-f9f8a6b29aef" providerId="ADAL" clId="{39DE2C0E-7095-495B-81F3-37AFAFAFC50B}" dt="2026-07-24T08:36:15.583" v="86" actId="20577"/>
+          <ac:spMkLst>
+            <pc:docMk/>
+            <pc:sldMk cId="649949001" sldId="263"/>
+            <ac:spMk id="2" creationId="{75D55EFF-BAF8-76D9-34DD-5A95E7620935}"/>
+          </ac:spMkLst>
+        </pc:spChg>
+      </pc:sldChg>
+      <pc:sldChg chg="modSp new del mod">
+        <pc:chgData name="Savannah Karin Miller" userId="22c948fc-cece-4b89-9db3-f9f8a6b29aef" providerId="ADAL" clId="{39DE2C0E-7095-495B-81F3-37AFAFAFC50B}" dt="2026-07-24T22:30:19.156" v="340" actId="2696"/>
+        <pc:sldMkLst>
+          <pc:docMk/>
+          <pc:sldMk cId="2282794336" sldId="264"/>
+        </pc:sldMkLst>
+        <pc:spChg chg="mod">
+          <ac:chgData name="Savannah Karin Miller" userId="22c948fc-cece-4b89-9db3-f9f8a6b29aef" providerId="ADAL" clId="{39DE2C0E-7095-495B-81F3-37AFAFAFC50B}" dt="2026-07-24T08:36:24.284" v="99" actId="20577"/>
+          <ac:spMkLst>
+            <pc:docMk/>
+            <pc:sldMk cId="2282794336" sldId="264"/>
+            <ac:spMk id="2" creationId="{D74124DD-0BE2-1DEA-8A8E-7193FAEE4CD5}"/>
+          </ac:spMkLst>
+        </pc:spChg>
+      </pc:sldChg>
+      <pc:sldChg chg="delSp add del mod">
+        <pc:chgData name="Savannah Karin Miller" userId="22c948fc-cece-4b89-9db3-f9f8a6b29aef" providerId="ADAL" clId="{39DE2C0E-7095-495B-81F3-37AFAFAFC50B}" dt="2026-07-24T22:28:02.119" v="295" actId="2696"/>
+        <pc:sldMkLst>
+          <pc:docMk/>
+          <pc:sldMk cId="2787838000" sldId="265"/>
+        </pc:sldMkLst>
+        <pc:picChg chg="del">
+          <ac:chgData name="Savannah Karin Miller" userId="22c948fc-cece-4b89-9db3-f9f8a6b29aef" providerId="ADAL" clId="{39DE2C0E-7095-495B-81F3-37AFAFAFC50B}" dt="2026-07-24T22:27:36.125" v="290" actId="21"/>
+          <ac:picMkLst>
+            <pc:docMk/>
+            <pc:sldMk cId="2787838000" sldId="265"/>
+            <ac:picMk id="7" creationId="{1A0D79C1-1E83-80C9-8204-47BC6930A4E8}"/>
+          </ac:picMkLst>
+        </pc:picChg>
+        <pc:picChg chg="del">
+          <ac:chgData name="Savannah Karin Miller" userId="22c948fc-cece-4b89-9db3-f9f8a6b29aef" providerId="ADAL" clId="{39DE2C0E-7095-495B-81F3-37AFAFAFC50B}" dt="2026-07-24T22:27:58.876" v="294" actId="478"/>
+          <ac:picMkLst>
+            <pc:docMk/>
+            <pc:sldMk cId="2787838000" sldId="265"/>
+            <ac:picMk id="11" creationId="{27A9125E-1CA4-14F7-A85B-B31610A27F89}"/>
+          </ac:picMkLst>
+        </pc:picChg>
+      </pc:sldChg>
+      <pc:sldChg chg="delSp add del mod">
+        <pc:chgData name="Savannah Karin Miller" userId="22c948fc-cece-4b89-9db3-f9f8a6b29aef" providerId="ADAL" clId="{39DE2C0E-7095-495B-81F3-37AFAFAFC50B}" dt="2026-07-24T22:30:07.738" v="335" actId="2696"/>
+        <pc:sldMkLst>
+          <pc:docMk/>
+          <pc:sldMk cId="2970447689" sldId="266"/>
+        </pc:sldMkLst>
+        <pc:picChg chg="del">
+          <ac:chgData name="Savannah Karin Miller" userId="22c948fc-cece-4b89-9db3-f9f8a6b29aef" providerId="ADAL" clId="{39DE2C0E-7095-495B-81F3-37AFAFAFC50B}" dt="2026-07-24T22:27:44.276" v="292" actId="478"/>
+          <ac:picMkLst>
+            <pc:docMk/>
+            <pc:sldMk cId="2970447689" sldId="266"/>
+            <ac:picMk id="7" creationId="{B8FB652E-ACF1-2334-9ED6-C9E1695525D9}"/>
+          </ac:picMkLst>
+        </pc:picChg>
+        <pc:picChg chg="del">
+          <ac:chgData name="Savannah Karin Miller" userId="22c948fc-cece-4b89-9db3-f9f8a6b29aef" providerId="ADAL" clId="{39DE2C0E-7095-495B-81F3-37AFAFAFC50B}" dt="2026-07-24T22:27:48.318" v="293" actId="478"/>
+          <ac:picMkLst>
+            <pc:docMk/>
+            <pc:sldMk cId="2970447689" sldId="266"/>
+            <ac:picMk id="11" creationId="{9DB8CC9C-C7C6-68AA-D9B1-AA49DC1F5336}"/>
+          </ac:picMkLst>
+        </pc:picChg>
+      </pc:sldChg>
+      <pc:sldChg chg="modSp add mod ord">
+        <pc:chgData name="Savannah Karin Miller" userId="22c948fc-cece-4b89-9db3-f9f8a6b29aef" providerId="ADAL" clId="{39DE2C0E-7095-495B-81F3-37AFAFAFC50B}" dt="2026-07-24T22:36:21.648" v="367"/>
+        <pc:sldMkLst>
+          <pc:docMk/>
+          <pc:sldMk cId="190303329" sldId="267"/>
+        </pc:sldMkLst>
+        <pc:spChg chg="mod">
+          <ac:chgData name="Savannah Karin Miller" userId="22c948fc-cece-4b89-9db3-f9f8a6b29aef" providerId="ADAL" clId="{39DE2C0E-7095-495B-81F3-37AFAFAFC50B}" dt="2026-07-24T22:27:31.147" v="289" actId="20577"/>
+          <ac:spMkLst>
+            <pc:docMk/>
+            <pc:sldMk cId="190303329" sldId="267"/>
+            <ac:spMk id="2" creationId="{570E7DC7-33DC-24D7-C010-A80F61FDE81E}"/>
+          </ac:spMkLst>
+        </pc:spChg>
+        <pc:graphicFrameChg chg="modGraphic">
+          <ac:chgData name="Savannah Karin Miller" userId="22c948fc-cece-4b89-9db3-f9f8a6b29aef" providerId="ADAL" clId="{39DE2C0E-7095-495B-81F3-37AFAFAFC50B}" dt="2026-07-24T22:31:57.006" v="348"/>
+          <ac:graphicFrameMkLst>
+            <pc:docMk/>
+            <pc:sldMk cId="190303329" sldId="267"/>
+            <ac:graphicFrameMk id="13" creationId="{7F2D9524-3E55-CDB4-DE4A-B09A9BBC0694}"/>
+          </ac:graphicFrameMkLst>
+        </pc:graphicFrameChg>
+      </pc:sldChg>
+      <pc:sldChg chg="modSp add mod ord setBg">
+        <pc:chgData name="Savannah Karin Miller" userId="22c948fc-cece-4b89-9db3-f9f8a6b29aef" providerId="ADAL" clId="{39DE2C0E-7095-495B-81F3-37AFAFAFC50B}" dt="2026-07-24T22:36:20.074" v="365"/>
+        <pc:sldMkLst>
+          <pc:docMk/>
+          <pc:sldMk cId="2522611454" sldId="268"/>
+        </pc:sldMkLst>
+        <pc:spChg chg="mod">
+          <ac:chgData name="Savannah Karin Miller" userId="22c948fc-cece-4b89-9db3-f9f8a6b29aef" providerId="ADAL" clId="{39DE2C0E-7095-495B-81F3-37AFAFAFC50B}" dt="2026-07-24T22:29:01.716" v="321" actId="20577"/>
+          <ac:spMkLst>
+            <pc:docMk/>
+            <pc:sldMk cId="2522611454" sldId="268"/>
+            <ac:spMk id="2" creationId="{F127ECE8-46AB-8A7D-4ED1-FD113CFF477A}"/>
+          </ac:spMkLst>
+        </pc:spChg>
+        <pc:graphicFrameChg chg="modGraphic">
+          <ac:chgData name="Savannah Karin Miller" userId="22c948fc-cece-4b89-9db3-f9f8a6b29aef" providerId="ADAL" clId="{39DE2C0E-7095-495B-81F3-37AFAFAFC50B}" dt="2026-07-24T22:35:13.403" v="361"/>
+          <ac:graphicFrameMkLst>
+            <pc:docMk/>
+            <pc:sldMk cId="2522611454" sldId="268"/>
+            <ac:graphicFrameMk id="13" creationId="{088074A2-91A8-3AF8-E4D4-AC22D04236BC}"/>
+          </ac:graphicFrameMkLst>
+        </pc:graphicFrameChg>
+      </pc:sldChg>
+      <pc:sldChg chg="modSp add mod ord">
+        <pc:chgData name="Savannah Karin Miller" userId="22c948fc-cece-4b89-9db3-f9f8a6b29aef" providerId="ADAL" clId="{39DE2C0E-7095-495B-81F3-37AFAFAFC50B}" dt="2026-07-24T22:36:17.919" v="363"/>
+        <pc:sldMkLst>
+          <pc:docMk/>
+          <pc:sldMk cId="3384073862" sldId="269"/>
+        </pc:sldMkLst>
+        <pc:spChg chg="mod">
+          <ac:chgData name="Savannah Karin Miller" userId="22c948fc-cece-4b89-9db3-f9f8a6b29aef" providerId="ADAL" clId="{39DE2C0E-7095-495B-81F3-37AFAFAFC50B}" dt="2026-07-24T22:29:14.286" v="326" actId="20577"/>
+          <ac:spMkLst>
+            <pc:docMk/>
+            <pc:sldMk cId="3384073862" sldId="269"/>
+            <ac:spMk id="2" creationId="{3481195E-87D6-1774-5870-4A08FAA4E34C}"/>
+          </ac:spMkLst>
+        </pc:spChg>
+        <pc:graphicFrameChg chg="modGraphic">
+          <ac:chgData name="Savannah Karin Miller" userId="22c948fc-cece-4b89-9db3-f9f8a6b29aef" providerId="ADAL" clId="{39DE2C0E-7095-495B-81F3-37AFAFAFC50B}" dt="2026-07-24T22:35:04.079" v="360"/>
+          <ac:graphicFrameMkLst>
+            <pc:docMk/>
+            <pc:sldMk cId="3384073862" sldId="269"/>
+            <ac:graphicFrameMk id="13" creationId="{65961CDC-CA8C-1E27-BEAC-E7B40747D916}"/>
+          </ac:graphicFrameMkLst>
+        </pc:graphicFrameChg>
+      </pc:sldChg>
+      <pc:sldChg chg="modSp add mod">
+        <pc:chgData name="Savannah Karin Miller" userId="22c948fc-cece-4b89-9db3-f9f8a6b29aef" providerId="ADAL" clId="{39DE2C0E-7095-495B-81F3-37AFAFAFC50B}" dt="2026-07-24T22:39:13.317" v="426"/>
+        <pc:sldMkLst>
+          <pc:docMk/>
+          <pc:sldMk cId="3706405986" sldId="270"/>
+        </pc:sldMkLst>
+        <pc:spChg chg="mod">
+          <ac:chgData name="Savannah Karin Miller" userId="22c948fc-cece-4b89-9db3-f9f8a6b29aef" providerId="ADAL" clId="{39DE2C0E-7095-495B-81F3-37AFAFAFC50B}" dt="2026-07-24T22:37:45.641" v="417" actId="20577"/>
+          <ac:spMkLst>
+            <pc:docMk/>
+            <pc:sldMk cId="3706405986" sldId="270"/>
+            <ac:spMk id="2" creationId="{EFF118FF-4596-E8CE-D9B4-3895B67AA369}"/>
+          </ac:spMkLst>
+        </pc:spChg>
+        <pc:graphicFrameChg chg="modGraphic">
+          <ac:chgData name="Savannah Karin Miller" userId="22c948fc-cece-4b89-9db3-f9f8a6b29aef" providerId="ADAL" clId="{39DE2C0E-7095-495B-81F3-37AFAFAFC50B}" dt="2026-07-24T22:39:13.317" v="426"/>
+          <ac:graphicFrameMkLst>
+            <pc:docMk/>
+            <pc:sldMk cId="3706405986" sldId="270"/>
+            <ac:graphicFrameMk id="13" creationId="{2652BB47-BCF7-71E2-16D9-FB7D8D86AF74}"/>
+          </ac:graphicFrameMkLst>
+        </pc:graphicFrameChg>
+      </pc:sldChg>
+      <pc:sldChg chg="add del">
+        <pc:chgData name="Savannah Karin Miller" userId="22c948fc-cece-4b89-9db3-f9f8a6b29aef" providerId="ADAL" clId="{39DE2C0E-7095-495B-81F3-37AFAFAFC50B}" dt="2026-07-24T23:35:05.749" v="427" actId="2696"/>
+        <pc:sldMkLst>
+          <pc:docMk/>
+          <pc:sldMk cId="1994676433" sldId="271"/>
+        </pc:sldMkLst>
       </pc:sldChg>
     </pc:docChg>
   </pc:docChgLst>
 </pc:chgInfo>
+</file>
+
+<file path=ppt/notesMasters/notesMaster1.xml><?xml version="1.0" encoding="utf-8"?>
+<p:notesMaster xmlns:a="http://schemas.openxmlformats.org/drawingml/2006/main" xmlns:r="http://schemas.openxmlformats.org/officeDocument/2006/relationships" xmlns:p="http://schemas.openxmlformats.org/presentationml/2006/main">
+  <p:cSld>
+    <p:bg>
+      <p:bgRef idx="1001">
+        <a:schemeClr val="bg1"/>
+      </p:bgRef>
+    </p:bg>
+    <p:spTree>
+      <p:nvGrpSpPr>
+        <p:cNvPr id="1" name=""/>
+        <p:cNvGrpSpPr/>
+        <p:nvPr/>
+      </p:nvGrpSpPr>
+      <p:grpSpPr>
+        <a:xfrm>
+          <a:off x="0" y="0"/>
+          <a:ext cx="0" cy="0"/>
+          <a:chOff x="0" y="0"/>
+          <a:chExt cx="0" cy="0"/>
+        </a:xfrm>
+      </p:grpSpPr>
+      <p:sp>
+        <p:nvSpPr>
+          <p:cNvPr id="2" name="Header Placeholder 1"/>
+          <p:cNvSpPr>
+            <a:spLocks noGrp="1"/>
+          </p:cNvSpPr>
+          <p:nvPr>
+            <p:ph type="hdr" sz="quarter"/>
+          </p:nvPr>
+        </p:nvSpPr>
+        <p:spPr>
+          <a:xfrm>
+            <a:off x="0" y="0"/>
+            <a:ext cx="2971800" cy="458788"/>
+          </a:xfrm>
+          <a:prstGeom prst="rect">
+            <a:avLst/>
+          </a:prstGeom>
+        </p:spPr>
+        <p:txBody>
+          <a:bodyPr vert="horz" lIns="91440" tIns="45720" rIns="91440" bIns="45720" rtlCol="0"/>
+          <a:lstStyle>
+            <a:lvl1pPr algn="l">
+              <a:defRPr sz="1200"/>
+            </a:lvl1pPr>
+          </a:lstStyle>
+          <a:p>
+            <a:endParaRPr lang="en-US"/>
+          </a:p>
+        </p:txBody>
+      </p:sp>
+      <p:sp>
+        <p:nvSpPr>
+          <p:cNvPr id="3" name="Date Placeholder 2"/>
+          <p:cNvSpPr>
+            <a:spLocks noGrp="1"/>
+          </p:cNvSpPr>
+          <p:nvPr>
+            <p:ph type="dt" idx="1"/>
+          </p:nvPr>
+        </p:nvSpPr>
+        <p:spPr>
+          <a:xfrm>
+            <a:off x="3884613" y="0"/>
+            <a:ext cx="2971800" cy="458788"/>
+          </a:xfrm>
+          <a:prstGeom prst="rect">
+            <a:avLst/>
+          </a:prstGeom>
+        </p:spPr>
+        <p:txBody>
+          <a:bodyPr vert="horz" lIns="91440" tIns="45720" rIns="91440" bIns="45720" rtlCol="0"/>
+          <a:lstStyle>
+            <a:lvl1pPr algn="r">
+              <a:defRPr sz="1200"/>
+            </a:lvl1pPr>
+          </a:lstStyle>
+          <a:p>
+            <a:fld id="{6F23D858-15B6-4534-B1C7-05F77CE6AB70}" type="datetimeFigureOut">
+              <a:rPr lang="en-US" smtClean="0"/>
+              <a:t>7/24/2026</a:t>
+            </a:fld>
+            <a:endParaRPr lang="en-US"/>
+          </a:p>
+        </p:txBody>
+      </p:sp>
+      <p:sp>
+        <p:nvSpPr>
+          <p:cNvPr id="4" name="Slide Image Placeholder 3"/>
+          <p:cNvSpPr>
+            <a:spLocks noGrp="1" noRot="1" noChangeAspect="1"/>
+          </p:cNvSpPr>
+          <p:nvPr>
+            <p:ph type="sldImg" idx="2"/>
+          </p:nvPr>
+        </p:nvSpPr>
+        <p:spPr>
+          <a:xfrm>
+            <a:off x="685800" y="1143000"/>
+            <a:ext cx="5486400" cy="3086100"/>
+          </a:xfrm>
+          <a:prstGeom prst="rect">
+            <a:avLst/>
+          </a:prstGeom>
+          <a:noFill/>
+          <a:ln w="12700">
+            <a:solidFill>
+              <a:prstClr val="black"/>
+            </a:solidFill>
+          </a:ln>
+        </p:spPr>
+        <p:txBody>
+          <a:bodyPr vert="horz" lIns="91440" tIns="45720" rIns="91440" bIns="45720" rtlCol="0" anchor="ctr"/>
+          <a:lstStyle/>
+          <a:p>
+            <a:endParaRPr lang="en-US"/>
+          </a:p>
+        </p:txBody>
+      </p:sp>
+      <p:sp>
+        <p:nvSpPr>
+          <p:cNvPr id="5" name="Notes Placeholder 4"/>
+          <p:cNvSpPr>
+            <a:spLocks noGrp="1"/>
+          </p:cNvSpPr>
+          <p:nvPr>
+            <p:ph type="body" sz="quarter" idx="3"/>
+          </p:nvPr>
+        </p:nvSpPr>
+        <p:spPr>
+          <a:xfrm>
+            <a:off x="685800" y="4400550"/>
+            <a:ext cx="5486400" cy="3600450"/>
+          </a:xfrm>
+          <a:prstGeom prst="rect">
+            <a:avLst/>
+          </a:prstGeom>
+        </p:spPr>
+        <p:txBody>
+          <a:bodyPr vert="horz" lIns="91440" tIns="45720" rIns="91440" bIns="45720" rtlCol="0"/>
+          <a:lstStyle/>
+          <a:p>
+            <a:pPr lvl="0"/>
+            <a:r>
+              <a:rPr lang="en-US"/>
+              <a:t>Click to edit Master text styles</a:t>
+            </a:r>
+          </a:p>
+          <a:p>
+            <a:pPr lvl="1"/>
+            <a:r>
+              <a:rPr lang="en-US"/>
+              <a:t>Second level</a:t>
+            </a:r>
+          </a:p>
+          <a:p>
+            <a:pPr lvl="2"/>
+            <a:r>
+              <a:rPr lang="en-US"/>
+              <a:t>Third level</a:t>
+            </a:r>
+          </a:p>
+          <a:p>
+            <a:pPr lvl="3"/>
+            <a:r>
+              <a:rPr lang="en-US"/>
+              <a:t>Fourth level</a:t>
+            </a:r>
+          </a:p>
+          <a:p>
+            <a:pPr lvl="4"/>
+            <a:r>
+              <a:rPr lang="en-US"/>
+              <a:t>Fifth level</a:t>
+            </a:r>
+          </a:p>
+        </p:txBody>
+      </p:sp>
+      <p:sp>
+        <p:nvSpPr>
+          <p:cNvPr id="6" name="Footer Placeholder 5"/>
+          <p:cNvSpPr>
+            <a:spLocks noGrp="1"/>
+          </p:cNvSpPr>
+          <p:nvPr>
+            <p:ph type="ftr" sz="quarter" idx="4"/>
+          </p:nvPr>
+        </p:nvSpPr>
+        <p:spPr>
+          <a:xfrm>
+            <a:off x="0" y="8685213"/>
+            <a:ext cx="2971800" cy="458787"/>
+          </a:xfrm>
+          <a:prstGeom prst="rect">
+            <a:avLst/>
+          </a:prstGeom>
+        </p:spPr>
+        <p:txBody>
+          <a:bodyPr vert="horz" lIns="91440" tIns="45720" rIns="91440" bIns="45720" rtlCol="0" anchor="b"/>
+          <a:lstStyle>
+            <a:lvl1pPr algn="l">
+              <a:defRPr sz="1200"/>
+            </a:lvl1pPr>
+          </a:lstStyle>
+          <a:p>
+            <a:endParaRPr lang="en-US"/>
+          </a:p>
+        </p:txBody>
+      </p:sp>
+      <p:sp>
+        <p:nvSpPr>
+          <p:cNvPr id="7" name="Slide Number Placeholder 6"/>
+          <p:cNvSpPr>
+            <a:spLocks noGrp="1"/>
+          </p:cNvSpPr>
+          <p:nvPr>
+            <p:ph type="sldNum" sz="quarter" idx="5"/>
+          </p:nvPr>
+        </p:nvSpPr>
+        <p:spPr>
+          <a:xfrm>
+            <a:off x="3884613" y="8685213"/>
+            <a:ext cx="2971800" cy="458787"/>
+          </a:xfrm>
+          <a:prstGeom prst="rect">
+            <a:avLst/>
+          </a:prstGeom>
+        </p:spPr>
+        <p:txBody>
+          <a:bodyPr vert="horz" lIns="91440" tIns="45720" rIns="91440" bIns="45720" rtlCol="0" anchor="b"/>
+          <a:lstStyle>
+            <a:lvl1pPr algn="r">
+              <a:defRPr sz="1200"/>
+            </a:lvl1pPr>
+          </a:lstStyle>
+          <a:p>
+            <a:fld id="{05CB3C10-79D3-4676-9629-5936076339B2}" type="slidenum">
+              <a:rPr lang="en-US" smtClean="0"/>
+              <a:t>‹#›</a:t>
+            </a:fld>
+            <a:endParaRPr lang="en-US"/>
+          </a:p>
+        </p:txBody>
+      </p:sp>
+    </p:spTree>
+    <p:extLst>
+      <p:ext uri="{BB962C8B-B14F-4D97-AF65-F5344CB8AC3E}">
+        <p14:creationId xmlns:p14="http://schemas.microsoft.com/office/powerpoint/2010/main" val="105321665"/>
+      </p:ext>
+    </p:extLst>
+  </p:cSld>
+  <p:clrMap bg1="lt1" tx1="dk1" bg2="lt2" tx2="dk2" accent1="accent1" accent2="accent2" accent3="accent3" accent4="accent4" accent5="accent5" accent6="accent6" hlink="hlink" folHlink="folHlink"/>
+  <p:notesStyle>
+    <a:lvl1pPr marL="0" algn="l" defTabSz="914400" rtl="0" eaLnBrk="1" latinLnBrk="0" hangingPunct="1">
+      <a:defRPr sz="1200" kern="1200">
+        <a:solidFill>
+          <a:schemeClr val="tx1"/>
+        </a:solidFill>
+        <a:latin typeface="+mn-lt"/>
+        <a:ea typeface="+mn-ea"/>
+        <a:cs typeface="+mn-cs"/>
+      </a:defRPr>
+    </a:lvl1pPr>
+    <a:lvl2pPr marL="457200" algn="l" defTabSz="914400" rtl="0" eaLnBrk="1" latinLnBrk="0" hangingPunct="1">
+      <a:defRPr sz="1200" kern="1200">
+        <a:solidFill>
+          <a:schemeClr val="tx1"/>
+        </a:solidFill>
+        <a:latin typeface="+mn-lt"/>
+        <a:ea typeface="+mn-ea"/>
+        <a:cs typeface="+mn-cs"/>
+      </a:defRPr>
+    </a:lvl2pPr>
+    <a:lvl3pPr marL="914400" algn="l" defTabSz="914400" rtl="0" eaLnBrk="1" latinLnBrk="0" hangingPunct="1">
+      <a:defRPr sz="1200" kern="1200">
+        <a:solidFill>
+          <a:schemeClr val="tx1"/>
+        </a:solidFill>
+        <a:latin typeface="+mn-lt"/>
+        <a:ea typeface="+mn-ea"/>
+        <a:cs typeface="+mn-cs"/>
+      </a:defRPr>
+    </a:lvl3pPr>
+    <a:lvl4pPr marL="1371600" algn="l" defTabSz="914400" rtl="0" eaLnBrk="1" latinLnBrk="0" hangingPunct="1">
+      <a:defRPr sz="1200" kern="1200">
+        <a:solidFill>
+          <a:schemeClr val="tx1"/>
+        </a:solidFill>
+        <a:latin typeface="+mn-lt"/>
+        <a:ea typeface="+mn-ea"/>
+        <a:cs typeface="+mn-cs"/>
+      </a:defRPr>
+    </a:lvl4pPr>
+    <a:lvl5pPr marL="1828800" algn="l" defTabSz="914400" rtl="0" eaLnBrk="1" latinLnBrk="0" hangingPunct="1">
+      <a:defRPr sz="1200" kern="1200">
+        <a:solidFill>
+          <a:schemeClr val="tx1"/>
+        </a:solidFill>
+        <a:latin typeface="+mn-lt"/>
+        <a:ea typeface="+mn-ea"/>
+        <a:cs typeface="+mn-cs"/>
+      </a:defRPr>
+    </a:lvl5pPr>
+    <a:lvl6pPr marL="2286000" algn="l" defTabSz="914400" rtl="0" eaLnBrk="1" latinLnBrk="0" hangingPunct="1">
+      <a:defRPr sz="1200" kern="1200">
+        <a:solidFill>
+          <a:schemeClr val="tx1"/>
+        </a:solidFill>
+        <a:latin typeface="+mn-lt"/>
+        <a:ea typeface="+mn-ea"/>
+        <a:cs typeface="+mn-cs"/>
+      </a:defRPr>
+    </a:lvl6pPr>
+    <a:lvl7pPr marL="2743200" algn="l" defTabSz="914400" rtl="0" eaLnBrk="1" latinLnBrk="0" hangingPunct="1">
+      <a:defRPr sz="1200" kern="1200">
+        <a:solidFill>
+          <a:schemeClr val="tx1"/>
+        </a:solidFill>
+        <a:latin typeface="+mn-lt"/>
+        <a:ea typeface="+mn-ea"/>
+        <a:cs typeface="+mn-cs"/>
+      </a:defRPr>
+    </a:lvl7pPr>
+    <a:lvl8pPr marL="3200400" algn="l" defTabSz="914400" rtl="0" eaLnBrk="1" latinLnBrk="0" hangingPunct="1">
+      <a:defRPr sz="1200" kern="1200">
+        <a:solidFill>
+          <a:schemeClr val="tx1"/>
+        </a:solidFill>
+        <a:latin typeface="+mn-lt"/>
+        <a:ea typeface="+mn-ea"/>
+        <a:cs typeface="+mn-cs"/>
+      </a:defRPr>
+    </a:lvl8pPr>
+    <a:lvl9pPr marL="3657600" algn="l" defTabSz="914400" rtl="0" eaLnBrk="1" latinLnBrk="0" hangingPunct="1">
+      <a:defRPr sz="1200" kern="1200">
+        <a:solidFill>
+          <a:schemeClr val="tx1"/>
+        </a:solidFill>
+        <a:latin typeface="+mn-lt"/>
+        <a:ea typeface="+mn-ea"/>
+        <a:cs typeface="+mn-cs"/>
+      </a:defRPr>
+    </a:lvl9pPr>
+  </p:notesStyle>
+</p:notesMaster>
+</file>
+
+<file path=ppt/notesSlides/notesSlide1.xml><?xml version="1.0" encoding="utf-8"?>
+<p:notes xmlns:a="http://schemas.openxmlformats.org/drawingml/2006/main" xmlns:r="http://schemas.openxmlformats.org/officeDocument/2006/relationships" xmlns:p="http://schemas.openxmlformats.org/presentationml/2006/main">
+  <p:cSld>
+    <p:spTree>
+      <p:nvGrpSpPr>
+        <p:cNvPr id="1" name=""/>
+        <p:cNvGrpSpPr/>
+        <p:nvPr/>
+      </p:nvGrpSpPr>
+      <p:grpSpPr>
+        <a:xfrm>
+          <a:off x="0" y="0"/>
+          <a:ext cx="0" cy="0"/>
+          <a:chOff x="0" y="0"/>
+          <a:chExt cx="0" cy="0"/>
+        </a:xfrm>
+      </p:grpSpPr>
+      <p:sp>
+        <p:nvSpPr>
+          <p:cNvPr id="2" name="Slide Image Placeholder 1"/>
+          <p:cNvSpPr>
+            <a:spLocks noGrp="1" noRot="1" noChangeAspect="1"/>
+          </p:cNvSpPr>
+          <p:nvPr>
+            <p:ph type="sldImg"/>
+          </p:nvPr>
+        </p:nvSpPr>
+        <p:spPr/>
+      </p:sp>
+      <p:sp>
+        <p:nvSpPr>
+          <p:cNvPr id="3" name="Notes Placeholder 2"/>
+          <p:cNvSpPr>
+            <a:spLocks noGrp="1"/>
+          </p:cNvSpPr>
+          <p:nvPr>
+            <p:ph type="body" idx="1"/>
+          </p:nvPr>
+        </p:nvSpPr>
+        <p:spPr/>
+        <p:txBody>
+          <a:bodyPr/>
+          <a:lstStyle/>
+          <a:p>
+            <a:r>
+              <a:rPr lang="en-US" dirty="0"/>
+              <a:t>PER DAYYYYY</a:t>
+            </a:r>
+          </a:p>
+        </p:txBody>
+      </p:sp>
+      <p:sp>
+        <p:nvSpPr>
+          <p:cNvPr id="4" name="Slide Number Placeholder 3"/>
+          <p:cNvSpPr>
+            <a:spLocks noGrp="1"/>
+          </p:cNvSpPr>
+          <p:nvPr>
+            <p:ph type="sldNum" sz="quarter" idx="5"/>
+          </p:nvPr>
+        </p:nvSpPr>
+        <p:spPr/>
+        <p:txBody>
+          <a:bodyPr/>
+          <a:lstStyle/>
+          <a:p>
+            <a:fld id="{05CB3C10-79D3-4676-9629-5936076339B2}" type="slidenum">
+              <a:rPr lang="en-US" smtClean="0"/>
+              <a:t>5</a:t>
+            </a:fld>
+            <a:endParaRPr lang="en-US"/>
+          </a:p>
+        </p:txBody>
+      </p:sp>
+    </p:spTree>
+    <p:extLst>
+      <p:ext uri="{BB962C8B-B14F-4D97-AF65-F5344CB8AC3E}">
+        <p14:creationId xmlns:p14="http://schemas.microsoft.com/office/powerpoint/2010/main" val="2254960287"/>
+      </p:ext>
+    </p:extLst>
+  </p:cSld>
+  <p:clrMapOvr>
+    <a:masterClrMapping/>
+  </p:clrMapOvr>
+</p:notes>
 </file>
 
 <file path=ppt/slideLayouts/slideLayout1.xml><?xml version="1.0" encoding="utf-8"?>
@@ -3438,7 +4272,13 @@
   <p:cSld>
     <p:spTree>
       <p:nvGrpSpPr>
-        <p:cNvPr id="1" name=""/>
+        <p:cNvPr id="1" name="">
+          <a:extLst>
+            <a:ext uri="{FF2B5EF4-FFF2-40B4-BE49-F238E27FC236}">
+              <a16:creationId xmlns:a16="http://schemas.microsoft.com/office/drawing/2014/main" id="{1A0EC22C-19BD-B5FC-E5AC-D88FB5B0583C}"/>
+            </a:ext>
+          </a:extLst>
+        </p:cNvPr>
         <p:cNvGrpSpPr/>
         <p:nvPr/>
       </p:nvGrpSpPr>
@@ -3455,7 +4295,7 @@
           <p:cNvPr id="2" name="Title 1">
             <a:extLst>
               <a:ext uri="{FF2B5EF4-FFF2-40B4-BE49-F238E27FC236}">
-                <a16:creationId xmlns:a16="http://schemas.microsoft.com/office/drawing/2014/main" id="{695C182A-678A-6134-65A2-0E938BE8159D}"/>
+                <a16:creationId xmlns:a16="http://schemas.microsoft.com/office/drawing/2014/main" id="{3481195E-87D6-1774-5870-4A08FAA4E34C}"/>
               </a:ext>
             </a:extLst>
           </p:cNvPr>
@@ -3466,47 +4306,256 @@
             <p:ph type="title"/>
           </p:nvPr>
         </p:nvSpPr>
-        <p:spPr/>
-        <p:txBody>
-          <a:bodyPr/>
+        <p:spPr>
+          <a:xfrm>
+            <a:off x="1495425" y="0"/>
+            <a:ext cx="9201149" cy="263524"/>
+          </a:xfrm>
+        </p:spPr>
+        <p:txBody>
+          <a:bodyPr>
+            <a:normAutofit fontScale="90000"/>
+          </a:bodyPr>
           <a:lstStyle/>
           <a:p>
-            <a:r>
-              <a:rPr lang="en-US" dirty="0"/>
-              <a:t>Buck’s Landing</a:t>
-            </a:r>
-          </a:p>
-        </p:txBody>
-      </p:sp>
-      <p:sp>
-        <p:nvSpPr>
-          <p:cNvPr id="3" name="Content Placeholder 2">
-            <a:extLst>
-              <a:ext uri="{FF2B5EF4-FFF2-40B4-BE49-F238E27FC236}">
-                <a16:creationId xmlns:a16="http://schemas.microsoft.com/office/drawing/2014/main" id="{B7594FA6-6FF4-3761-215A-ADE5662B2B3A}"/>
-              </a:ext>
-            </a:extLst>
-          </p:cNvPr>
-          <p:cNvSpPr>
-            <a:spLocks noGrp="1"/>
-          </p:cNvSpPr>
-          <p:nvPr>
-            <p:ph idx="1"/>
-          </p:nvPr>
-        </p:nvSpPr>
-        <p:spPr/>
-        <p:txBody>
-          <a:bodyPr/>
-          <a:lstStyle/>
-          <a:p>
-            <a:endParaRPr lang="en-US"/>
-          </a:p>
-        </p:txBody>
-      </p:sp>
+            <a:pPr algn="ctr"/>
+            <a:r>
+              <a:rPr lang="en-US" sz="2800" b="1" u="sng" dirty="0"/>
+              <a:t>Flag Type By Time</a:t>
+            </a:r>
+          </a:p>
+        </p:txBody>
+      </p:sp>
+      <p:graphicFrame>
+        <p:nvGraphicFramePr>
+          <p:cNvPr id="13" name="Table 12">
+            <a:extLst>
+              <a:ext uri="{FF2B5EF4-FFF2-40B4-BE49-F238E27FC236}">
+                <a16:creationId xmlns:a16="http://schemas.microsoft.com/office/drawing/2014/main" id="{65961CDC-CA8C-1E27-BEAC-E7B40747D916}"/>
+              </a:ext>
+            </a:extLst>
+          </p:cNvPr>
+          <p:cNvGraphicFramePr>
+            <a:graphicFrameLocks noGrp="1"/>
+          </p:cNvGraphicFramePr>
+          <p:nvPr>
+            <p:extLst>
+              <p:ext uri="{D42A27DB-BD31-4B8C-83A1-F6EECF244321}">
+                <p14:modId xmlns:p14="http://schemas.microsoft.com/office/powerpoint/2010/main" val="301702648"/>
+              </p:ext>
+            </p:extLst>
+          </p:nvPr>
+        </p:nvGraphicFramePr>
+        <p:xfrm>
+          <a:off x="0" y="285750"/>
+          <a:ext cx="12192000" cy="6572250"/>
+        </p:xfrm>
+        <a:graphic>
+          <a:graphicData uri="http://schemas.openxmlformats.org/drawingml/2006/table">
+            <a:tbl>
+              <a:tblPr firstRow="1" bandRow="1">
+                <a:tableStyleId>{5940675A-B579-460E-94D1-54222C63F5DA}</a:tableStyleId>
+              </a:tblPr>
+              <a:tblGrid>
+                <a:gridCol w="6096000">
+                  <a:extLst>
+                    <a:ext uri="{9D8B030D-6E8A-4147-A177-3AD203B41FA5}">
+                      <a16:colId xmlns:a16="http://schemas.microsoft.com/office/drawing/2014/main" val="3630680804"/>
+                    </a:ext>
+                  </a:extLst>
+                </a:gridCol>
+                <a:gridCol w="6096000">
+                  <a:extLst>
+                    <a:ext uri="{9D8B030D-6E8A-4147-A177-3AD203B41FA5}">
+                      <a16:colId xmlns:a16="http://schemas.microsoft.com/office/drawing/2014/main" val="338354109"/>
+                    </a:ext>
+                  </a:extLst>
+                </a:gridCol>
+              </a:tblGrid>
+              <a:tr h="331423">
+                <a:tc>
+                  <a:txBody>
+                    <a:bodyPr/>
+                    <a:lstStyle/>
+                    <a:p>
+                      <a:pPr algn="ctr"/>
+                      <a:r>
+                        <a:rPr lang="en-US" sz="1400" b="1" i="1" dirty="0"/>
+                        <a:t>Buck’s Landing</a:t>
+                      </a:r>
+                    </a:p>
+                  </a:txBody>
+                  <a:tcPr>
+                    <a:solidFill>
+                      <a:schemeClr val="bg2">
+                        <a:lumMod val="75000"/>
+                      </a:schemeClr>
+                    </a:solidFill>
+                  </a:tcPr>
+                </a:tc>
+                <a:tc>
+                  <a:txBody>
+                    <a:bodyPr/>
+                    <a:lstStyle/>
+                    <a:p>
+                      <a:pPr algn="ctr"/>
+                      <a:r>
+                        <a:rPr lang="en-US" sz="1400" b="1" i="1" dirty="0"/>
+                        <a:t>San Pablo</a:t>
+                      </a:r>
+                    </a:p>
+                  </a:txBody>
+                  <a:tcPr>
+                    <a:solidFill>
+                      <a:schemeClr val="bg2">
+                        <a:lumMod val="75000"/>
+                      </a:schemeClr>
+                    </a:solidFill>
+                  </a:tcPr>
+                </a:tc>
+                <a:extLst>
+                  <a:ext uri="{0D108BD9-81ED-4DB2-BD59-A6C34878D82A}">
+                    <a16:rowId xmlns:a16="http://schemas.microsoft.com/office/drawing/2014/main" val="3725292629"/>
+                  </a:ext>
+                </a:extLst>
+              </a:tr>
+              <a:tr h="2982842">
+                <a:tc>
+                  <a:txBody>
+                    <a:bodyPr/>
+                    <a:lstStyle/>
+                    <a:p>
+                      <a:endParaRPr lang="en-US" dirty="0"/>
+                    </a:p>
+                  </a:txBody>
+                  <a:tcPr>
+                    <a:blipFill>
+                      <a:blip r:embed="rId2"/>
+                      <a:stretch>
+                        <a:fillRect/>
+                      </a:stretch>
+                    </a:blipFill>
+                  </a:tcPr>
+                </a:tc>
+                <a:tc>
+                  <a:txBody>
+                    <a:bodyPr/>
+                    <a:lstStyle/>
+                    <a:p>
+                      <a:endParaRPr lang="en-US" dirty="0"/>
+                    </a:p>
+                  </a:txBody>
+                  <a:tcPr>
+                    <a:blipFill>
+                      <a:blip r:embed="rId3"/>
+                      <a:stretch>
+                        <a:fillRect/>
+                      </a:stretch>
+                    </a:blipFill>
+                  </a:tcPr>
+                </a:tc>
+                <a:extLst>
+                  <a:ext uri="{0D108BD9-81ED-4DB2-BD59-A6C34878D82A}">
+                    <a16:rowId xmlns:a16="http://schemas.microsoft.com/office/drawing/2014/main" val="3941593418"/>
+                  </a:ext>
+                </a:extLst>
+              </a:tr>
+              <a:tr h="331423">
+                <a:tc>
+                  <a:txBody>
+                    <a:bodyPr/>
+                    <a:lstStyle/>
+                    <a:p>
+                      <a:pPr algn="ctr"/>
+                      <a:r>
+                        <a:rPr lang="en-US" sz="1400" b="1" i="1" dirty="0"/>
+                        <a:t>Corte Madera</a:t>
+                      </a:r>
+                    </a:p>
+                  </a:txBody>
+                  <a:tcPr>
+                    <a:solidFill>
+                      <a:schemeClr val="bg2">
+                        <a:lumMod val="75000"/>
+                      </a:schemeClr>
+                    </a:solidFill>
+                  </a:tcPr>
+                </a:tc>
+                <a:tc>
+                  <a:txBody>
+                    <a:bodyPr/>
+                    <a:lstStyle/>
+                    <a:p>
+                      <a:pPr algn="ctr"/>
+                      <a:r>
+                        <a:rPr lang="en-US" sz="1400" b="1" i="1" dirty="0"/>
+                        <a:t>Giant Marsh </a:t>
+                      </a:r>
+                    </a:p>
+                  </a:txBody>
+                  <a:tcPr>
+                    <a:solidFill>
+                      <a:schemeClr val="bg2">
+                        <a:lumMod val="75000"/>
+                      </a:schemeClr>
+                    </a:solidFill>
+                  </a:tcPr>
+                </a:tc>
+                <a:extLst>
+                  <a:ext uri="{0D108BD9-81ED-4DB2-BD59-A6C34878D82A}">
+                    <a16:rowId xmlns:a16="http://schemas.microsoft.com/office/drawing/2014/main" val="718732893"/>
+                  </a:ext>
+                </a:extLst>
+              </a:tr>
+              <a:tr h="2926562">
+                <a:tc>
+                  <a:txBody>
+                    <a:bodyPr/>
+                    <a:lstStyle/>
+                    <a:p>
+                      <a:endParaRPr lang="en-US" dirty="0"/>
+                    </a:p>
+                  </a:txBody>
+                  <a:tcPr>
+                    <a:blipFill>
+                      <a:blip r:embed="rId4"/>
+                      <a:stretch>
+                        <a:fillRect/>
+                      </a:stretch>
+                    </a:blipFill>
+                  </a:tcPr>
+                </a:tc>
+                <a:tc>
+                  <a:txBody>
+                    <a:bodyPr/>
+                    <a:lstStyle/>
+                    <a:p>
+                      <a:endParaRPr lang="en-US" dirty="0"/>
+                    </a:p>
+                  </a:txBody>
+                  <a:tcPr>
+                    <a:blipFill>
+                      <a:blip r:embed="rId5"/>
+                      <a:stretch>
+                        <a:fillRect/>
+                      </a:stretch>
+                    </a:blipFill>
+                  </a:tcPr>
+                </a:tc>
+                <a:extLst>
+                  <a:ext uri="{0D108BD9-81ED-4DB2-BD59-A6C34878D82A}">
+                    <a16:rowId xmlns:a16="http://schemas.microsoft.com/office/drawing/2014/main" val="4090644053"/>
+                  </a:ext>
+                </a:extLst>
+              </a:tr>
+            </a:tbl>
+          </a:graphicData>
+        </a:graphic>
+      </p:graphicFrame>
     </p:spTree>
     <p:extLst>
       <p:ext uri="{BB962C8B-B14F-4D97-AF65-F5344CB8AC3E}">
-        <p14:creationId xmlns:p14="http://schemas.microsoft.com/office/powerpoint/2010/main" val="4186647946"/>
+        <p14:creationId xmlns:p14="http://schemas.microsoft.com/office/powerpoint/2010/main" val="3384073862"/>
       </p:ext>
     </p:extLst>
   </p:cSld>
@@ -3519,9 +4568,29 @@
 <file path=ppt/slides/slide3.xml><?xml version="1.0" encoding="utf-8"?>
 <p:sld xmlns:a="http://schemas.openxmlformats.org/drawingml/2006/main" xmlns:r="http://schemas.openxmlformats.org/officeDocument/2006/relationships" xmlns:p="http://schemas.openxmlformats.org/presentationml/2006/main">
   <p:cSld>
+    <p:bg>
+      <p:bgPr>
+        <a:blipFill dpi="0" rotWithShape="1">
+          <a:blip r:embed="rId2">
+            <a:lum/>
+          </a:blip>
+          <a:srcRect/>
+          <a:stretch>
+            <a:fillRect t="-5000" b="-5000"/>
+          </a:stretch>
+        </a:blipFill>
+        <a:effectLst/>
+      </p:bgPr>
+    </p:bg>
     <p:spTree>
       <p:nvGrpSpPr>
-        <p:cNvPr id="1" name=""/>
+        <p:cNvPr id="1" name="">
+          <a:extLst>
+            <a:ext uri="{FF2B5EF4-FFF2-40B4-BE49-F238E27FC236}">
+              <a16:creationId xmlns:a16="http://schemas.microsoft.com/office/drawing/2014/main" id="{5363C75B-597C-75A6-CAFA-3050066EACEC}"/>
+            </a:ext>
+          </a:extLst>
+        </p:cNvPr>
         <p:cNvGrpSpPr/>
         <p:nvPr/>
       </p:nvGrpSpPr>
@@ -3538,7 +4607,7 @@
           <p:cNvPr id="2" name="Title 1">
             <a:extLst>
               <a:ext uri="{FF2B5EF4-FFF2-40B4-BE49-F238E27FC236}">
-                <a16:creationId xmlns:a16="http://schemas.microsoft.com/office/drawing/2014/main" id="{8527E45A-8081-E213-241C-4FD628CA8AD6}"/>
+                <a16:creationId xmlns:a16="http://schemas.microsoft.com/office/drawing/2014/main" id="{F127ECE8-46AB-8A7D-4ED1-FD113CFF477A}"/>
               </a:ext>
             </a:extLst>
           </p:cNvPr>
@@ -3549,47 +4618,256 @@
             <p:ph type="title"/>
           </p:nvPr>
         </p:nvSpPr>
-        <p:spPr/>
-        <p:txBody>
-          <a:bodyPr/>
+        <p:spPr>
+          <a:xfrm>
+            <a:off x="1495425" y="0"/>
+            <a:ext cx="9201149" cy="263524"/>
+          </a:xfrm>
+        </p:spPr>
+        <p:txBody>
+          <a:bodyPr>
+            <a:normAutofit fontScale="90000"/>
+          </a:bodyPr>
           <a:lstStyle/>
           <a:p>
-            <a:r>
-              <a:rPr lang="en-US" dirty="0"/>
-              <a:t>Giant Marsh </a:t>
-            </a:r>
-          </a:p>
-        </p:txBody>
-      </p:sp>
-      <p:sp>
-        <p:nvSpPr>
-          <p:cNvPr id="3" name="Content Placeholder 2">
-            <a:extLst>
-              <a:ext uri="{FF2B5EF4-FFF2-40B4-BE49-F238E27FC236}">
-                <a16:creationId xmlns:a16="http://schemas.microsoft.com/office/drawing/2014/main" id="{C2C3EA00-06DD-DF86-26AE-43C89419A4E7}"/>
-              </a:ext>
-            </a:extLst>
-          </p:cNvPr>
-          <p:cNvSpPr>
-            <a:spLocks noGrp="1"/>
-          </p:cNvSpPr>
-          <p:nvPr>
-            <p:ph idx="1"/>
-          </p:nvPr>
-        </p:nvSpPr>
-        <p:spPr/>
-        <p:txBody>
-          <a:bodyPr/>
-          <a:lstStyle/>
-          <a:p>
-            <a:endParaRPr lang="en-US"/>
-          </a:p>
-        </p:txBody>
-      </p:sp>
+            <a:pPr algn="ctr"/>
+            <a:r>
+              <a:rPr lang="en-US" sz="2800" b="1" u="sng" dirty="0"/>
+              <a:t>Flag Type By Distance</a:t>
+            </a:r>
+          </a:p>
+        </p:txBody>
+      </p:sp>
+      <p:graphicFrame>
+        <p:nvGraphicFramePr>
+          <p:cNvPr id="13" name="Table 12">
+            <a:extLst>
+              <a:ext uri="{FF2B5EF4-FFF2-40B4-BE49-F238E27FC236}">
+                <a16:creationId xmlns:a16="http://schemas.microsoft.com/office/drawing/2014/main" id="{088074A2-91A8-3AF8-E4D4-AC22D04236BC}"/>
+              </a:ext>
+            </a:extLst>
+          </p:cNvPr>
+          <p:cNvGraphicFramePr>
+            <a:graphicFrameLocks noGrp="1"/>
+          </p:cNvGraphicFramePr>
+          <p:nvPr>
+            <p:extLst>
+              <p:ext uri="{D42A27DB-BD31-4B8C-83A1-F6EECF244321}">
+                <p14:modId xmlns:p14="http://schemas.microsoft.com/office/powerpoint/2010/main" val="2400470680"/>
+              </p:ext>
+            </p:extLst>
+          </p:nvPr>
+        </p:nvGraphicFramePr>
+        <p:xfrm>
+          <a:off x="0" y="285750"/>
+          <a:ext cx="12192000" cy="6572250"/>
+        </p:xfrm>
+        <a:graphic>
+          <a:graphicData uri="http://schemas.openxmlformats.org/drawingml/2006/table">
+            <a:tbl>
+              <a:tblPr firstRow="1" bandRow="1">
+                <a:tableStyleId>{5940675A-B579-460E-94D1-54222C63F5DA}</a:tableStyleId>
+              </a:tblPr>
+              <a:tblGrid>
+                <a:gridCol w="6096000">
+                  <a:extLst>
+                    <a:ext uri="{9D8B030D-6E8A-4147-A177-3AD203B41FA5}">
+                      <a16:colId xmlns:a16="http://schemas.microsoft.com/office/drawing/2014/main" val="3630680804"/>
+                    </a:ext>
+                  </a:extLst>
+                </a:gridCol>
+                <a:gridCol w="6096000">
+                  <a:extLst>
+                    <a:ext uri="{9D8B030D-6E8A-4147-A177-3AD203B41FA5}">
+                      <a16:colId xmlns:a16="http://schemas.microsoft.com/office/drawing/2014/main" val="338354109"/>
+                    </a:ext>
+                  </a:extLst>
+                </a:gridCol>
+              </a:tblGrid>
+              <a:tr h="331423">
+                <a:tc>
+                  <a:txBody>
+                    <a:bodyPr/>
+                    <a:lstStyle/>
+                    <a:p>
+                      <a:pPr algn="ctr"/>
+                      <a:r>
+                        <a:rPr lang="en-US" sz="1400" b="1" i="1" dirty="0"/>
+                        <a:t>Buck’s Landing</a:t>
+                      </a:r>
+                    </a:p>
+                  </a:txBody>
+                  <a:tcPr>
+                    <a:solidFill>
+                      <a:schemeClr val="bg2">
+                        <a:lumMod val="75000"/>
+                      </a:schemeClr>
+                    </a:solidFill>
+                  </a:tcPr>
+                </a:tc>
+                <a:tc>
+                  <a:txBody>
+                    <a:bodyPr/>
+                    <a:lstStyle/>
+                    <a:p>
+                      <a:pPr algn="ctr"/>
+                      <a:r>
+                        <a:rPr lang="en-US" sz="1400" b="1" i="1" dirty="0"/>
+                        <a:t>San Pablo</a:t>
+                      </a:r>
+                    </a:p>
+                  </a:txBody>
+                  <a:tcPr>
+                    <a:solidFill>
+                      <a:schemeClr val="bg2">
+                        <a:lumMod val="75000"/>
+                      </a:schemeClr>
+                    </a:solidFill>
+                  </a:tcPr>
+                </a:tc>
+                <a:extLst>
+                  <a:ext uri="{0D108BD9-81ED-4DB2-BD59-A6C34878D82A}">
+                    <a16:rowId xmlns:a16="http://schemas.microsoft.com/office/drawing/2014/main" val="3725292629"/>
+                  </a:ext>
+                </a:extLst>
+              </a:tr>
+              <a:tr h="2982842">
+                <a:tc>
+                  <a:txBody>
+                    <a:bodyPr/>
+                    <a:lstStyle/>
+                    <a:p>
+                      <a:endParaRPr lang="en-US" dirty="0"/>
+                    </a:p>
+                  </a:txBody>
+                  <a:tcPr>
+                    <a:blipFill>
+                      <a:blip r:embed="rId3"/>
+                      <a:stretch>
+                        <a:fillRect/>
+                      </a:stretch>
+                    </a:blipFill>
+                  </a:tcPr>
+                </a:tc>
+                <a:tc>
+                  <a:txBody>
+                    <a:bodyPr/>
+                    <a:lstStyle/>
+                    <a:p>
+                      <a:endParaRPr lang="en-US" dirty="0"/>
+                    </a:p>
+                  </a:txBody>
+                  <a:tcPr>
+                    <a:blipFill>
+                      <a:blip r:embed="rId4"/>
+                      <a:stretch>
+                        <a:fillRect/>
+                      </a:stretch>
+                    </a:blipFill>
+                  </a:tcPr>
+                </a:tc>
+                <a:extLst>
+                  <a:ext uri="{0D108BD9-81ED-4DB2-BD59-A6C34878D82A}">
+                    <a16:rowId xmlns:a16="http://schemas.microsoft.com/office/drawing/2014/main" val="3941593418"/>
+                  </a:ext>
+                </a:extLst>
+              </a:tr>
+              <a:tr h="331423">
+                <a:tc>
+                  <a:txBody>
+                    <a:bodyPr/>
+                    <a:lstStyle/>
+                    <a:p>
+                      <a:pPr algn="ctr"/>
+                      <a:r>
+                        <a:rPr lang="en-US" sz="1400" b="1" i="1" dirty="0"/>
+                        <a:t>Corte Madera</a:t>
+                      </a:r>
+                    </a:p>
+                  </a:txBody>
+                  <a:tcPr>
+                    <a:solidFill>
+                      <a:schemeClr val="bg2">
+                        <a:lumMod val="75000"/>
+                      </a:schemeClr>
+                    </a:solidFill>
+                  </a:tcPr>
+                </a:tc>
+                <a:tc>
+                  <a:txBody>
+                    <a:bodyPr/>
+                    <a:lstStyle/>
+                    <a:p>
+                      <a:pPr algn="ctr"/>
+                      <a:r>
+                        <a:rPr lang="en-US" sz="1400" b="1" i="1" dirty="0"/>
+                        <a:t>Giant Marsh </a:t>
+                      </a:r>
+                    </a:p>
+                  </a:txBody>
+                  <a:tcPr>
+                    <a:solidFill>
+                      <a:schemeClr val="bg2">
+                        <a:lumMod val="75000"/>
+                      </a:schemeClr>
+                    </a:solidFill>
+                  </a:tcPr>
+                </a:tc>
+                <a:extLst>
+                  <a:ext uri="{0D108BD9-81ED-4DB2-BD59-A6C34878D82A}">
+                    <a16:rowId xmlns:a16="http://schemas.microsoft.com/office/drawing/2014/main" val="718732893"/>
+                  </a:ext>
+                </a:extLst>
+              </a:tr>
+              <a:tr h="2926562">
+                <a:tc>
+                  <a:txBody>
+                    <a:bodyPr/>
+                    <a:lstStyle/>
+                    <a:p>
+                      <a:endParaRPr lang="en-US" dirty="0"/>
+                    </a:p>
+                  </a:txBody>
+                  <a:tcPr>
+                    <a:blipFill>
+                      <a:blip r:embed="rId5"/>
+                      <a:stretch>
+                        <a:fillRect/>
+                      </a:stretch>
+                    </a:blipFill>
+                  </a:tcPr>
+                </a:tc>
+                <a:tc>
+                  <a:txBody>
+                    <a:bodyPr/>
+                    <a:lstStyle/>
+                    <a:p>
+                      <a:endParaRPr lang="en-US" dirty="0"/>
+                    </a:p>
+                  </a:txBody>
+                  <a:tcPr>
+                    <a:blipFill>
+                      <a:blip r:embed="rId6"/>
+                      <a:stretch>
+                        <a:fillRect/>
+                      </a:stretch>
+                    </a:blipFill>
+                  </a:tcPr>
+                </a:tc>
+                <a:extLst>
+                  <a:ext uri="{0D108BD9-81ED-4DB2-BD59-A6C34878D82A}">
+                    <a16:rowId xmlns:a16="http://schemas.microsoft.com/office/drawing/2014/main" val="4090644053"/>
+                  </a:ext>
+                </a:extLst>
+              </a:tr>
+            </a:tbl>
+          </a:graphicData>
+        </a:graphic>
+      </p:graphicFrame>
     </p:spTree>
     <p:extLst>
       <p:ext uri="{BB962C8B-B14F-4D97-AF65-F5344CB8AC3E}">
-        <p14:creationId xmlns:p14="http://schemas.microsoft.com/office/powerpoint/2010/main" val="2631489723"/>
+        <p14:creationId xmlns:p14="http://schemas.microsoft.com/office/powerpoint/2010/main" val="2522611454"/>
       </p:ext>
     </p:extLst>
   </p:cSld>
@@ -3604,7 +4882,13 @@
   <p:cSld>
     <p:spTree>
       <p:nvGrpSpPr>
-        <p:cNvPr id="1" name=""/>
+        <p:cNvPr id="1" name="">
+          <a:extLst>
+            <a:ext uri="{FF2B5EF4-FFF2-40B4-BE49-F238E27FC236}">
+              <a16:creationId xmlns:a16="http://schemas.microsoft.com/office/drawing/2014/main" id="{97082EA7-C1EF-719D-181B-8BA2368DCFEE}"/>
+            </a:ext>
+          </a:extLst>
+        </p:cNvPr>
         <p:cNvGrpSpPr/>
         <p:nvPr/>
       </p:nvGrpSpPr>
@@ -3621,7 +4905,7 @@
           <p:cNvPr id="2" name="Title 1">
             <a:extLst>
               <a:ext uri="{FF2B5EF4-FFF2-40B4-BE49-F238E27FC236}">
-                <a16:creationId xmlns:a16="http://schemas.microsoft.com/office/drawing/2014/main" id="{5575BC85-2EBE-28B3-5369-796383BE1631}"/>
+                <a16:creationId xmlns:a16="http://schemas.microsoft.com/office/drawing/2014/main" id="{570E7DC7-33DC-24D7-C010-A80F61FDE81E}"/>
               </a:ext>
             </a:extLst>
           </p:cNvPr>
@@ -3632,47 +4916,256 @@
             <p:ph type="title"/>
           </p:nvPr>
         </p:nvSpPr>
-        <p:spPr/>
-        <p:txBody>
-          <a:bodyPr/>
+        <p:spPr>
+          <a:xfrm>
+            <a:off x="1495425" y="0"/>
+            <a:ext cx="9201149" cy="263524"/>
+          </a:xfrm>
+        </p:spPr>
+        <p:txBody>
+          <a:bodyPr>
+            <a:normAutofit fontScale="90000"/>
+          </a:bodyPr>
           <a:lstStyle/>
           <a:p>
-            <a:r>
-              <a:rPr lang="en-US" dirty="0"/>
-              <a:t>Corte Madera </a:t>
-            </a:r>
-          </a:p>
-        </p:txBody>
-      </p:sp>
-      <p:sp>
-        <p:nvSpPr>
-          <p:cNvPr id="3" name="Content Placeholder 2">
-            <a:extLst>
-              <a:ext uri="{FF2B5EF4-FFF2-40B4-BE49-F238E27FC236}">
-                <a16:creationId xmlns:a16="http://schemas.microsoft.com/office/drawing/2014/main" id="{7F0274A5-47C8-40D7-1495-26FF47F98D20}"/>
-              </a:ext>
-            </a:extLst>
-          </p:cNvPr>
-          <p:cNvSpPr>
-            <a:spLocks noGrp="1"/>
-          </p:cNvSpPr>
-          <p:nvPr>
-            <p:ph idx="1"/>
-          </p:nvPr>
-        </p:nvSpPr>
-        <p:spPr/>
-        <p:txBody>
-          <a:bodyPr/>
-          <a:lstStyle/>
-          <a:p>
-            <a:endParaRPr lang="en-US"/>
-          </a:p>
-        </p:txBody>
-      </p:sp>
+            <a:pPr algn="ctr"/>
+            <a:r>
+              <a:rPr lang="en-US" sz="2800" b="1" u="sng" dirty="0"/>
+              <a:t>Co-Occurrence of Flag Type</a:t>
+            </a:r>
+          </a:p>
+        </p:txBody>
+      </p:sp>
+      <p:graphicFrame>
+        <p:nvGraphicFramePr>
+          <p:cNvPr id="13" name="Table 12">
+            <a:extLst>
+              <a:ext uri="{FF2B5EF4-FFF2-40B4-BE49-F238E27FC236}">
+                <a16:creationId xmlns:a16="http://schemas.microsoft.com/office/drawing/2014/main" id="{7F2D9524-3E55-CDB4-DE4A-B09A9BBC0694}"/>
+              </a:ext>
+            </a:extLst>
+          </p:cNvPr>
+          <p:cNvGraphicFramePr>
+            <a:graphicFrameLocks noGrp="1"/>
+          </p:cNvGraphicFramePr>
+          <p:nvPr>
+            <p:extLst>
+              <p:ext uri="{D42A27DB-BD31-4B8C-83A1-F6EECF244321}">
+                <p14:modId xmlns:p14="http://schemas.microsoft.com/office/powerpoint/2010/main" val="2062177243"/>
+              </p:ext>
+            </p:extLst>
+          </p:nvPr>
+        </p:nvGraphicFramePr>
+        <p:xfrm>
+          <a:off x="0" y="285750"/>
+          <a:ext cx="12192000" cy="6572250"/>
+        </p:xfrm>
+        <a:graphic>
+          <a:graphicData uri="http://schemas.openxmlformats.org/drawingml/2006/table">
+            <a:tbl>
+              <a:tblPr firstRow="1" bandRow="1">
+                <a:tableStyleId>{5940675A-B579-460E-94D1-54222C63F5DA}</a:tableStyleId>
+              </a:tblPr>
+              <a:tblGrid>
+                <a:gridCol w="6096000">
+                  <a:extLst>
+                    <a:ext uri="{9D8B030D-6E8A-4147-A177-3AD203B41FA5}">
+                      <a16:colId xmlns:a16="http://schemas.microsoft.com/office/drawing/2014/main" val="3630680804"/>
+                    </a:ext>
+                  </a:extLst>
+                </a:gridCol>
+                <a:gridCol w="6096000">
+                  <a:extLst>
+                    <a:ext uri="{9D8B030D-6E8A-4147-A177-3AD203B41FA5}">
+                      <a16:colId xmlns:a16="http://schemas.microsoft.com/office/drawing/2014/main" val="338354109"/>
+                    </a:ext>
+                  </a:extLst>
+                </a:gridCol>
+              </a:tblGrid>
+              <a:tr h="331423">
+                <a:tc>
+                  <a:txBody>
+                    <a:bodyPr/>
+                    <a:lstStyle/>
+                    <a:p>
+                      <a:pPr algn="ctr"/>
+                      <a:r>
+                        <a:rPr lang="en-US" sz="1400" b="1" i="1" dirty="0"/>
+                        <a:t>Buck’s Landing</a:t>
+                      </a:r>
+                    </a:p>
+                  </a:txBody>
+                  <a:tcPr>
+                    <a:solidFill>
+                      <a:schemeClr val="bg2">
+                        <a:lumMod val="75000"/>
+                      </a:schemeClr>
+                    </a:solidFill>
+                  </a:tcPr>
+                </a:tc>
+                <a:tc>
+                  <a:txBody>
+                    <a:bodyPr/>
+                    <a:lstStyle/>
+                    <a:p>
+                      <a:pPr algn="ctr"/>
+                      <a:r>
+                        <a:rPr lang="en-US" sz="1400" b="1" i="1" dirty="0"/>
+                        <a:t>San Pablo</a:t>
+                      </a:r>
+                    </a:p>
+                  </a:txBody>
+                  <a:tcPr>
+                    <a:solidFill>
+                      <a:schemeClr val="bg2">
+                        <a:lumMod val="75000"/>
+                      </a:schemeClr>
+                    </a:solidFill>
+                  </a:tcPr>
+                </a:tc>
+                <a:extLst>
+                  <a:ext uri="{0D108BD9-81ED-4DB2-BD59-A6C34878D82A}">
+                    <a16:rowId xmlns:a16="http://schemas.microsoft.com/office/drawing/2014/main" val="3725292629"/>
+                  </a:ext>
+                </a:extLst>
+              </a:tr>
+              <a:tr h="2982842">
+                <a:tc>
+                  <a:txBody>
+                    <a:bodyPr/>
+                    <a:lstStyle/>
+                    <a:p>
+                      <a:endParaRPr lang="en-US" dirty="0"/>
+                    </a:p>
+                  </a:txBody>
+                  <a:tcPr>
+                    <a:blipFill>
+                      <a:blip r:embed="rId2"/>
+                      <a:stretch>
+                        <a:fillRect/>
+                      </a:stretch>
+                    </a:blipFill>
+                  </a:tcPr>
+                </a:tc>
+                <a:tc>
+                  <a:txBody>
+                    <a:bodyPr/>
+                    <a:lstStyle/>
+                    <a:p>
+                      <a:endParaRPr lang="en-US" dirty="0"/>
+                    </a:p>
+                  </a:txBody>
+                  <a:tcPr>
+                    <a:blipFill>
+                      <a:blip r:embed="rId3"/>
+                      <a:stretch>
+                        <a:fillRect/>
+                      </a:stretch>
+                    </a:blipFill>
+                  </a:tcPr>
+                </a:tc>
+                <a:extLst>
+                  <a:ext uri="{0D108BD9-81ED-4DB2-BD59-A6C34878D82A}">
+                    <a16:rowId xmlns:a16="http://schemas.microsoft.com/office/drawing/2014/main" val="3941593418"/>
+                  </a:ext>
+                </a:extLst>
+              </a:tr>
+              <a:tr h="331423">
+                <a:tc>
+                  <a:txBody>
+                    <a:bodyPr/>
+                    <a:lstStyle/>
+                    <a:p>
+                      <a:pPr algn="ctr"/>
+                      <a:r>
+                        <a:rPr lang="en-US" sz="1400" b="1" i="1" dirty="0"/>
+                        <a:t>Corte Madera</a:t>
+                      </a:r>
+                    </a:p>
+                  </a:txBody>
+                  <a:tcPr>
+                    <a:solidFill>
+                      <a:schemeClr val="bg2">
+                        <a:lumMod val="75000"/>
+                      </a:schemeClr>
+                    </a:solidFill>
+                  </a:tcPr>
+                </a:tc>
+                <a:tc>
+                  <a:txBody>
+                    <a:bodyPr/>
+                    <a:lstStyle/>
+                    <a:p>
+                      <a:pPr algn="ctr"/>
+                      <a:r>
+                        <a:rPr lang="en-US" sz="1400" b="1" i="1" dirty="0"/>
+                        <a:t>Giant Marsh </a:t>
+                      </a:r>
+                    </a:p>
+                  </a:txBody>
+                  <a:tcPr>
+                    <a:solidFill>
+                      <a:schemeClr val="bg2">
+                        <a:lumMod val="75000"/>
+                      </a:schemeClr>
+                    </a:solidFill>
+                  </a:tcPr>
+                </a:tc>
+                <a:extLst>
+                  <a:ext uri="{0D108BD9-81ED-4DB2-BD59-A6C34878D82A}">
+                    <a16:rowId xmlns:a16="http://schemas.microsoft.com/office/drawing/2014/main" val="718732893"/>
+                  </a:ext>
+                </a:extLst>
+              </a:tr>
+              <a:tr h="2926562">
+                <a:tc>
+                  <a:txBody>
+                    <a:bodyPr/>
+                    <a:lstStyle/>
+                    <a:p>
+                      <a:endParaRPr lang="en-US" dirty="0"/>
+                    </a:p>
+                  </a:txBody>
+                  <a:tcPr>
+                    <a:blipFill>
+                      <a:blip r:embed="rId4"/>
+                      <a:stretch>
+                        <a:fillRect/>
+                      </a:stretch>
+                    </a:blipFill>
+                  </a:tcPr>
+                </a:tc>
+                <a:tc>
+                  <a:txBody>
+                    <a:bodyPr/>
+                    <a:lstStyle/>
+                    <a:p>
+                      <a:endParaRPr lang="en-US" dirty="0"/>
+                    </a:p>
+                  </a:txBody>
+                  <a:tcPr>
+                    <a:blipFill>
+                      <a:blip r:embed="rId5"/>
+                      <a:stretch>
+                        <a:fillRect/>
+                      </a:stretch>
+                    </a:blipFill>
+                  </a:tcPr>
+                </a:tc>
+                <a:extLst>
+                  <a:ext uri="{0D108BD9-81ED-4DB2-BD59-A6C34878D82A}">
+                    <a16:rowId xmlns:a16="http://schemas.microsoft.com/office/drawing/2014/main" val="4090644053"/>
+                  </a:ext>
+                </a:extLst>
+              </a:tr>
+            </a:tbl>
+          </a:graphicData>
+        </a:graphic>
+      </p:graphicFrame>
     </p:spTree>
     <p:extLst>
       <p:ext uri="{BB962C8B-B14F-4D97-AF65-F5344CB8AC3E}">
-        <p14:creationId xmlns:p14="http://schemas.microsoft.com/office/powerpoint/2010/main" val="1853752826"/>
+        <p14:creationId xmlns:p14="http://schemas.microsoft.com/office/powerpoint/2010/main" val="190303329"/>
       </p:ext>
     </p:extLst>
   </p:cSld>
@@ -3704,7 +5197,7 @@
           <p:cNvPr id="2" name="Title 1">
             <a:extLst>
               <a:ext uri="{FF2B5EF4-FFF2-40B4-BE49-F238E27FC236}">
-                <a16:creationId xmlns:a16="http://schemas.microsoft.com/office/drawing/2014/main" id="{7C38C012-7A5B-FBEA-8D5E-50C51513BAD3}"/>
+                <a16:creationId xmlns:a16="http://schemas.microsoft.com/office/drawing/2014/main" id="{695C182A-678A-6134-65A2-0E938BE8159D}"/>
               </a:ext>
             </a:extLst>
           </p:cNvPr>
@@ -3715,47 +5208,554 @@
             <p:ph type="title"/>
           </p:nvPr>
         </p:nvSpPr>
-        <p:spPr/>
-        <p:txBody>
-          <a:bodyPr/>
+        <p:spPr>
+          <a:xfrm>
+            <a:off x="1495425" y="0"/>
+            <a:ext cx="9201149" cy="263524"/>
+          </a:xfrm>
+        </p:spPr>
+        <p:txBody>
+          <a:bodyPr>
+            <a:normAutofit fontScale="90000"/>
+          </a:bodyPr>
           <a:lstStyle/>
           <a:p>
-            <a:r>
-              <a:rPr lang="en-US" dirty="0"/>
-              <a:t>San Pablo </a:t>
-            </a:r>
-          </a:p>
-        </p:txBody>
-      </p:sp>
-      <p:sp>
-        <p:nvSpPr>
-          <p:cNvPr id="3" name="Content Placeholder 2">
-            <a:extLst>
-              <a:ext uri="{FF2B5EF4-FFF2-40B4-BE49-F238E27FC236}">
-                <a16:creationId xmlns:a16="http://schemas.microsoft.com/office/drawing/2014/main" id="{E4F5D803-F367-5D18-11BD-A94E3442D25A}"/>
-              </a:ext>
-            </a:extLst>
-          </p:cNvPr>
-          <p:cNvSpPr>
-            <a:spLocks noGrp="1"/>
-          </p:cNvSpPr>
-          <p:nvPr>
-            <p:ph idx="1"/>
-          </p:nvPr>
-        </p:nvSpPr>
-        <p:spPr/>
-        <p:txBody>
-          <a:bodyPr/>
-          <a:lstStyle/>
-          <a:p>
-            <a:endParaRPr lang="en-US" dirty="0"/>
-          </a:p>
-        </p:txBody>
-      </p:sp>
+            <a:pPr algn="ctr"/>
+            <a:r>
+              <a:rPr lang="en-US" sz="2800" b="1" u="sng" dirty="0"/>
+              <a:t>Flux Distribution by QC Flag Type </a:t>
+            </a:r>
+          </a:p>
+        </p:txBody>
+      </p:sp>
+      <p:graphicFrame>
+        <p:nvGraphicFramePr>
+          <p:cNvPr id="13" name="Table 12">
+            <a:extLst>
+              <a:ext uri="{FF2B5EF4-FFF2-40B4-BE49-F238E27FC236}">
+                <a16:creationId xmlns:a16="http://schemas.microsoft.com/office/drawing/2014/main" id="{A8AA364A-5A65-A4AA-B115-25B477A5BC15}"/>
+              </a:ext>
+            </a:extLst>
+          </p:cNvPr>
+          <p:cNvGraphicFramePr>
+            <a:graphicFrameLocks noGrp="1"/>
+          </p:cNvGraphicFramePr>
+          <p:nvPr>
+            <p:extLst>
+              <p:ext uri="{D42A27DB-BD31-4B8C-83A1-F6EECF244321}">
+                <p14:modId xmlns:p14="http://schemas.microsoft.com/office/powerpoint/2010/main" val="2256579664"/>
+              </p:ext>
+            </p:extLst>
+          </p:nvPr>
+        </p:nvGraphicFramePr>
+        <p:xfrm>
+          <a:off x="0" y="285750"/>
+          <a:ext cx="12192000" cy="6572250"/>
+        </p:xfrm>
+        <a:graphic>
+          <a:graphicData uri="http://schemas.openxmlformats.org/drawingml/2006/table">
+            <a:tbl>
+              <a:tblPr firstRow="1" bandRow="1">
+                <a:tableStyleId>{5940675A-B579-460E-94D1-54222C63F5DA}</a:tableStyleId>
+              </a:tblPr>
+              <a:tblGrid>
+                <a:gridCol w="6096000">
+                  <a:extLst>
+                    <a:ext uri="{9D8B030D-6E8A-4147-A177-3AD203B41FA5}">
+                      <a16:colId xmlns:a16="http://schemas.microsoft.com/office/drawing/2014/main" val="3630680804"/>
+                    </a:ext>
+                  </a:extLst>
+                </a:gridCol>
+                <a:gridCol w="6096000">
+                  <a:extLst>
+                    <a:ext uri="{9D8B030D-6E8A-4147-A177-3AD203B41FA5}">
+                      <a16:colId xmlns:a16="http://schemas.microsoft.com/office/drawing/2014/main" val="338354109"/>
+                    </a:ext>
+                  </a:extLst>
+                </a:gridCol>
+              </a:tblGrid>
+              <a:tr h="331423">
+                <a:tc>
+                  <a:txBody>
+                    <a:bodyPr/>
+                    <a:lstStyle/>
+                    <a:p>
+                      <a:pPr algn="ctr"/>
+                      <a:r>
+                        <a:rPr lang="en-US" sz="1400" b="1" i="1" dirty="0"/>
+                        <a:t>Buck’s Landing</a:t>
+                      </a:r>
+                    </a:p>
+                  </a:txBody>
+                  <a:tcPr>
+                    <a:solidFill>
+                      <a:schemeClr val="bg2">
+                        <a:lumMod val="75000"/>
+                      </a:schemeClr>
+                    </a:solidFill>
+                  </a:tcPr>
+                </a:tc>
+                <a:tc>
+                  <a:txBody>
+                    <a:bodyPr/>
+                    <a:lstStyle/>
+                    <a:p>
+                      <a:pPr algn="ctr"/>
+                      <a:r>
+                        <a:rPr lang="en-US" sz="1400" b="1" i="1" dirty="0"/>
+                        <a:t>San Pablo</a:t>
+                      </a:r>
+                    </a:p>
+                  </a:txBody>
+                  <a:tcPr>
+                    <a:solidFill>
+                      <a:schemeClr val="bg2">
+                        <a:lumMod val="75000"/>
+                      </a:schemeClr>
+                    </a:solidFill>
+                  </a:tcPr>
+                </a:tc>
+                <a:extLst>
+                  <a:ext uri="{0D108BD9-81ED-4DB2-BD59-A6C34878D82A}">
+                    <a16:rowId xmlns:a16="http://schemas.microsoft.com/office/drawing/2014/main" val="3725292629"/>
+                  </a:ext>
+                </a:extLst>
+              </a:tr>
+              <a:tr h="2982842">
+                <a:tc>
+                  <a:txBody>
+                    <a:bodyPr/>
+                    <a:lstStyle/>
+                    <a:p>
+                      <a:endParaRPr lang="en-US" dirty="0"/>
+                    </a:p>
+                  </a:txBody>
+                  <a:tcPr>
+                    <a:blipFill>
+                      <a:blip r:embed="rId3"/>
+                      <a:stretch>
+                        <a:fillRect/>
+                      </a:stretch>
+                    </a:blipFill>
+                  </a:tcPr>
+                </a:tc>
+                <a:tc>
+                  <a:txBody>
+                    <a:bodyPr/>
+                    <a:lstStyle/>
+                    <a:p>
+                      <a:endParaRPr lang="en-US" dirty="0"/>
+                    </a:p>
+                  </a:txBody>
+                  <a:tcPr>
+                    <a:blipFill>
+                      <a:blip r:embed="rId4"/>
+                      <a:stretch>
+                        <a:fillRect/>
+                      </a:stretch>
+                    </a:blipFill>
+                  </a:tcPr>
+                </a:tc>
+                <a:extLst>
+                  <a:ext uri="{0D108BD9-81ED-4DB2-BD59-A6C34878D82A}">
+                    <a16:rowId xmlns:a16="http://schemas.microsoft.com/office/drawing/2014/main" val="3941593418"/>
+                  </a:ext>
+                </a:extLst>
+              </a:tr>
+              <a:tr h="331423">
+                <a:tc>
+                  <a:txBody>
+                    <a:bodyPr/>
+                    <a:lstStyle/>
+                    <a:p>
+                      <a:pPr algn="ctr"/>
+                      <a:r>
+                        <a:rPr lang="en-US" sz="1400" b="1" i="1" dirty="0"/>
+                        <a:t>Corte Madera</a:t>
+                      </a:r>
+                    </a:p>
+                  </a:txBody>
+                  <a:tcPr>
+                    <a:solidFill>
+                      <a:schemeClr val="bg2">
+                        <a:lumMod val="75000"/>
+                      </a:schemeClr>
+                    </a:solidFill>
+                  </a:tcPr>
+                </a:tc>
+                <a:tc>
+                  <a:txBody>
+                    <a:bodyPr/>
+                    <a:lstStyle/>
+                    <a:p>
+                      <a:pPr algn="ctr"/>
+                      <a:r>
+                        <a:rPr lang="en-US" sz="1400" b="1" i="1" dirty="0"/>
+                        <a:t>Giant Marsh </a:t>
+                      </a:r>
+                    </a:p>
+                  </a:txBody>
+                  <a:tcPr>
+                    <a:solidFill>
+                      <a:schemeClr val="bg2">
+                        <a:lumMod val="75000"/>
+                      </a:schemeClr>
+                    </a:solidFill>
+                  </a:tcPr>
+                </a:tc>
+                <a:extLst>
+                  <a:ext uri="{0D108BD9-81ED-4DB2-BD59-A6C34878D82A}">
+                    <a16:rowId xmlns:a16="http://schemas.microsoft.com/office/drawing/2014/main" val="718732893"/>
+                  </a:ext>
+                </a:extLst>
+              </a:tr>
+              <a:tr h="2926562">
+                <a:tc>
+                  <a:txBody>
+                    <a:bodyPr/>
+                    <a:lstStyle/>
+                    <a:p>
+                      <a:endParaRPr lang="en-US" dirty="0"/>
+                    </a:p>
+                  </a:txBody>
+                  <a:tcPr>
+                    <a:blipFill>
+                      <a:blip r:embed="rId5"/>
+                      <a:stretch>
+                        <a:fillRect/>
+                      </a:stretch>
+                    </a:blipFill>
+                  </a:tcPr>
+                </a:tc>
+                <a:tc>
+                  <a:txBody>
+                    <a:bodyPr/>
+                    <a:lstStyle/>
+                    <a:p>
+                      <a:endParaRPr lang="en-US" dirty="0"/>
+                    </a:p>
+                  </a:txBody>
+                  <a:tcPr>
+                    <a:blipFill>
+                      <a:blip r:embed="rId6"/>
+                      <a:stretch>
+                        <a:fillRect/>
+                      </a:stretch>
+                    </a:blipFill>
+                  </a:tcPr>
+                </a:tc>
+                <a:extLst>
+                  <a:ext uri="{0D108BD9-81ED-4DB2-BD59-A6C34878D82A}">
+                    <a16:rowId xmlns:a16="http://schemas.microsoft.com/office/drawing/2014/main" val="4090644053"/>
+                  </a:ext>
+                </a:extLst>
+              </a:tr>
+            </a:tbl>
+          </a:graphicData>
+        </a:graphic>
+      </p:graphicFrame>
     </p:spTree>
     <p:extLst>
       <p:ext uri="{BB962C8B-B14F-4D97-AF65-F5344CB8AC3E}">
-        <p14:creationId xmlns:p14="http://schemas.microsoft.com/office/powerpoint/2010/main" val="4083801371"/>
+        <p14:creationId xmlns:p14="http://schemas.microsoft.com/office/powerpoint/2010/main" val="4186647946"/>
+      </p:ext>
+    </p:extLst>
+  </p:cSld>
+  <p:clrMapOvr>
+    <a:masterClrMapping/>
+  </p:clrMapOvr>
+</p:sld>
+</file>
+
+<file path=ppt/slides/slide6.xml><?xml version="1.0" encoding="utf-8"?>
+<p:sld xmlns:a="http://schemas.openxmlformats.org/drawingml/2006/main" xmlns:r="http://schemas.openxmlformats.org/officeDocument/2006/relationships" xmlns:p="http://schemas.openxmlformats.org/presentationml/2006/main">
+  <p:cSld>
+    <p:spTree>
+      <p:nvGrpSpPr>
+        <p:cNvPr id="1" name="">
+          <a:extLst>
+            <a:ext uri="{FF2B5EF4-FFF2-40B4-BE49-F238E27FC236}">
+              <a16:creationId xmlns:a16="http://schemas.microsoft.com/office/drawing/2014/main" id="{A984B918-6C27-9D3E-A3BD-EF5579A76D54}"/>
+            </a:ext>
+          </a:extLst>
+        </p:cNvPr>
+        <p:cNvGrpSpPr/>
+        <p:nvPr/>
+      </p:nvGrpSpPr>
+      <p:grpSpPr>
+        <a:xfrm>
+          <a:off x="0" y="0"/>
+          <a:ext cx="0" cy="0"/>
+          <a:chOff x="0" y="0"/>
+          <a:chExt cx="0" cy="0"/>
+        </a:xfrm>
+      </p:grpSpPr>
+      <p:sp>
+        <p:nvSpPr>
+          <p:cNvPr id="2" name="Title 1">
+            <a:extLst>
+              <a:ext uri="{FF2B5EF4-FFF2-40B4-BE49-F238E27FC236}">
+                <a16:creationId xmlns:a16="http://schemas.microsoft.com/office/drawing/2014/main" id="{EFF118FF-4596-E8CE-D9B4-3895B67AA369}"/>
+              </a:ext>
+            </a:extLst>
+          </p:cNvPr>
+          <p:cNvSpPr>
+            <a:spLocks noGrp="1"/>
+          </p:cNvSpPr>
+          <p:nvPr>
+            <p:ph type="title"/>
+          </p:nvPr>
+        </p:nvSpPr>
+        <p:spPr>
+          <a:xfrm>
+            <a:off x="1495425" y="0"/>
+            <a:ext cx="9201149" cy="263524"/>
+          </a:xfrm>
+        </p:spPr>
+        <p:txBody>
+          <a:bodyPr>
+            <a:normAutofit fontScale="90000"/>
+          </a:bodyPr>
+          <a:lstStyle/>
+          <a:p>
+            <a:pPr algn="ctr"/>
+            <a:r>
+              <a:rPr lang="en-US" sz="2800" b="1" u="sng" dirty="0"/>
+              <a:t>Elevation and Distance For Flags</a:t>
+            </a:r>
+          </a:p>
+        </p:txBody>
+      </p:sp>
+      <p:graphicFrame>
+        <p:nvGraphicFramePr>
+          <p:cNvPr id="13" name="Table 12">
+            <a:extLst>
+              <a:ext uri="{FF2B5EF4-FFF2-40B4-BE49-F238E27FC236}">
+                <a16:creationId xmlns:a16="http://schemas.microsoft.com/office/drawing/2014/main" id="{2652BB47-BCF7-71E2-16D9-FB7D8D86AF74}"/>
+              </a:ext>
+            </a:extLst>
+          </p:cNvPr>
+          <p:cNvGraphicFramePr>
+            <a:graphicFrameLocks noGrp="1"/>
+          </p:cNvGraphicFramePr>
+          <p:nvPr>
+            <p:extLst>
+              <p:ext uri="{D42A27DB-BD31-4B8C-83A1-F6EECF244321}">
+                <p14:modId xmlns:p14="http://schemas.microsoft.com/office/powerpoint/2010/main" val="562022392"/>
+              </p:ext>
+            </p:extLst>
+          </p:nvPr>
+        </p:nvGraphicFramePr>
+        <p:xfrm>
+          <a:off x="0" y="285750"/>
+          <a:ext cx="12192000" cy="6572250"/>
+        </p:xfrm>
+        <a:graphic>
+          <a:graphicData uri="http://schemas.openxmlformats.org/drawingml/2006/table">
+            <a:tbl>
+              <a:tblPr firstRow="1" bandRow="1">
+                <a:tableStyleId>{5940675A-B579-460E-94D1-54222C63F5DA}</a:tableStyleId>
+              </a:tblPr>
+              <a:tblGrid>
+                <a:gridCol w="6096000">
+                  <a:extLst>
+                    <a:ext uri="{9D8B030D-6E8A-4147-A177-3AD203B41FA5}">
+                      <a16:colId xmlns:a16="http://schemas.microsoft.com/office/drawing/2014/main" val="3630680804"/>
+                    </a:ext>
+                  </a:extLst>
+                </a:gridCol>
+                <a:gridCol w="6096000">
+                  <a:extLst>
+                    <a:ext uri="{9D8B030D-6E8A-4147-A177-3AD203B41FA5}">
+                      <a16:colId xmlns:a16="http://schemas.microsoft.com/office/drawing/2014/main" val="338354109"/>
+                    </a:ext>
+                  </a:extLst>
+                </a:gridCol>
+              </a:tblGrid>
+              <a:tr h="331423">
+                <a:tc>
+                  <a:txBody>
+                    <a:bodyPr/>
+                    <a:lstStyle/>
+                    <a:p>
+                      <a:pPr algn="ctr"/>
+                      <a:r>
+                        <a:rPr lang="en-US" sz="1400" b="1" i="1" dirty="0"/>
+                        <a:t>Buck’s Landing</a:t>
+                      </a:r>
+                    </a:p>
+                  </a:txBody>
+                  <a:tcPr>
+                    <a:solidFill>
+                      <a:schemeClr val="bg2">
+                        <a:lumMod val="75000"/>
+                      </a:schemeClr>
+                    </a:solidFill>
+                  </a:tcPr>
+                </a:tc>
+                <a:tc>
+                  <a:txBody>
+                    <a:bodyPr/>
+                    <a:lstStyle/>
+                    <a:p>
+                      <a:pPr algn="ctr"/>
+                      <a:r>
+                        <a:rPr lang="en-US" sz="1400" b="1" i="1" dirty="0"/>
+                        <a:t>San Pablo</a:t>
+                      </a:r>
+                    </a:p>
+                  </a:txBody>
+                  <a:tcPr>
+                    <a:solidFill>
+                      <a:schemeClr val="bg2">
+                        <a:lumMod val="75000"/>
+                      </a:schemeClr>
+                    </a:solidFill>
+                  </a:tcPr>
+                </a:tc>
+                <a:extLst>
+                  <a:ext uri="{0D108BD9-81ED-4DB2-BD59-A6C34878D82A}">
+                    <a16:rowId xmlns:a16="http://schemas.microsoft.com/office/drawing/2014/main" val="3725292629"/>
+                  </a:ext>
+                </a:extLst>
+              </a:tr>
+              <a:tr h="2982842">
+                <a:tc>
+                  <a:txBody>
+                    <a:bodyPr/>
+                    <a:lstStyle/>
+                    <a:p>
+                      <a:endParaRPr lang="en-US" dirty="0"/>
+                    </a:p>
+                  </a:txBody>
+                  <a:tcPr>
+                    <a:blipFill>
+                      <a:blip r:embed="rId2"/>
+                      <a:stretch>
+                        <a:fillRect/>
+                      </a:stretch>
+                    </a:blipFill>
+                  </a:tcPr>
+                </a:tc>
+                <a:tc>
+                  <a:txBody>
+                    <a:bodyPr/>
+                    <a:lstStyle/>
+                    <a:p>
+                      <a:endParaRPr lang="en-US" dirty="0"/>
+                    </a:p>
+                  </a:txBody>
+                  <a:tcPr>
+                    <a:blipFill>
+                      <a:blip r:embed="rId3"/>
+                      <a:stretch>
+                        <a:fillRect/>
+                      </a:stretch>
+                    </a:blipFill>
+                  </a:tcPr>
+                </a:tc>
+                <a:extLst>
+                  <a:ext uri="{0D108BD9-81ED-4DB2-BD59-A6C34878D82A}">
+                    <a16:rowId xmlns:a16="http://schemas.microsoft.com/office/drawing/2014/main" val="3941593418"/>
+                  </a:ext>
+                </a:extLst>
+              </a:tr>
+              <a:tr h="331423">
+                <a:tc>
+                  <a:txBody>
+                    <a:bodyPr/>
+                    <a:lstStyle/>
+                    <a:p>
+                      <a:pPr algn="ctr"/>
+                      <a:r>
+                        <a:rPr lang="en-US" sz="1400" b="1" i="1" dirty="0"/>
+                        <a:t>Corte Madera</a:t>
+                      </a:r>
+                    </a:p>
+                  </a:txBody>
+                  <a:tcPr>
+                    <a:solidFill>
+                      <a:schemeClr val="bg2">
+                        <a:lumMod val="75000"/>
+                      </a:schemeClr>
+                    </a:solidFill>
+                  </a:tcPr>
+                </a:tc>
+                <a:tc>
+                  <a:txBody>
+                    <a:bodyPr/>
+                    <a:lstStyle/>
+                    <a:p>
+                      <a:pPr algn="ctr"/>
+                      <a:r>
+                        <a:rPr lang="en-US" sz="1400" b="1" i="1" dirty="0"/>
+                        <a:t>Giant Marsh </a:t>
+                      </a:r>
+                    </a:p>
+                  </a:txBody>
+                  <a:tcPr>
+                    <a:solidFill>
+                      <a:schemeClr val="bg2">
+                        <a:lumMod val="75000"/>
+                      </a:schemeClr>
+                    </a:solidFill>
+                  </a:tcPr>
+                </a:tc>
+                <a:extLst>
+                  <a:ext uri="{0D108BD9-81ED-4DB2-BD59-A6C34878D82A}">
+                    <a16:rowId xmlns:a16="http://schemas.microsoft.com/office/drawing/2014/main" val="718732893"/>
+                  </a:ext>
+                </a:extLst>
+              </a:tr>
+              <a:tr h="2926562">
+                <a:tc>
+                  <a:txBody>
+                    <a:bodyPr/>
+                    <a:lstStyle/>
+                    <a:p>
+                      <a:endParaRPr lang="en-US" dirty="0"/>
+                    </a:p>
+                  </a:txBody>
+                  <a:tcPr>
+                    <a:blipFill>
+                      <a:blip r:embed="rId4"/>
+                      <a:stretch>
+                        <a:fillRect/>
+                      </a:stretch>
+                    </a:blipFill>
+                  </a:tcPr>
+                </a:tc>
+                <a:tc>
+                  <a:txBody>
+                    <a:bodyPr/>
+                    <a:lstStyle/>
+                    <a:p>
+                      <a:endParaRPr lang="en-US" dirty="0"/>
+                    </a:p>
+                  </a:txBody>
+                  <a:tcPr>
+                    <a:blipFill>
+                      <a:blip r:embed="rId5"/>
+                      <a:stretch>
+                        <a:fillRect/>
+                      </a:stretch>
+                    </a:blipFill>
+                  </a:tcPr>
+                </a:tc>
+                <a:extLst>
+                  <a:ext uri="{0D108BD9-81ED-4DB2-BD59-A6C34878D82A}">
+                    <a16:rowId xmlns:a16="http://schemas.microsoft.com/office/drawing/2014/main" val="4090644053"/>
+                  </a:ext>
+                </a:extLst>
+              </a:tr>
+            </a:tbl>
+          </a:graphicData>
+        </a:graphic>
+      </p:graphicFrame>
+    </p:spTree>
+    <p:extLst>
+      <p:ext uri="{BB962C8B-B14F-4D97-AF65-F5344CB8AC3E}">
+        <p14:creationId xmlns:p14="http://schemas.microsoft.com/office/powerpoint/2010/main" val="3706405986"/>
       </p:ext>
     </p:extLst>
   </p:cSld>
@@ -4078,4 +6078,319 @@
     </a:ext>
   </a:extLst>
 </a:theme>
+</file>
+
+<file path=ppt/theme/theme2.xml><?xml version="1.0" encoding="utf-8"?>
+<a:theme xmlns:a="http://schemas.openxmlformats.org/drawingml/2006/main" name="Office Theme">
+  <a:themeElements>
+    <a:clrScheme name="Office">
+      <a:dk1>
+        <a:sysClr val="windowText" lastClr="000000"/>
+      </a:dk1>
+      <a:lt1>
+        <a:sysClr val="window" lastClr="FFFFFF"/>
+      </a:lt1>
+      <a:dk2>
+        <a:srgbClr val="0E2841"/>
+      </a:dk2>
+      <a:lt2>
+        <a:srgbClr val="E8E8E8"/>
+      </a:lt2>
+      <a:accent1>
+        <a:srgbClr val="156082"/>
+      </a:accent1>
+      <a:accent2>
+        <a:srgbClr val="E97132"/>
+      </a:accent2>
+      <a:accent3>
+        <a:srgbClr val="196B24"/>
+      </a:accent3>
+      <a:accent4>
+        <a:srgbClr val="0F9ED5"/>
+      </a:accent4>
+      <a:accent5>
+        <a:srgbClr val="A02B93"/>
+      </a:accent5>
+      <a:accent6>
+        <a:srgbClr val="4EA72E"/>
+      </a:accent6>
+      <a:hlink>
+        <a:srgbClr val="467886"/>
+      </a:hlink>
+      <a:folHlink>
+        <a:srgbClr val="96607D"/>
+      </a:folHlink>
+    </a:clrScheme>
+    <a:fontScheme name="Office">
+      <a:majorFont>
+        <a:latin typeface="Aptos Display" panose="02110004020202020204"/>
+        <a:ea typeface=""/>
+        <a:cs typeface=""/>
+        <a:font script="Jpan" typeface="游ゴシック Light"/>
+        <a:font script="Hang" typeface="맑은 고딕"/>
+        <a:font script="Hans" typeface="等线 Light"/>
+        <a:font script="Hant" typeface="新細明體"/>
+        <a:font script="Arab" typeface="Times New Roman"/>
+        <a:font script="Hebr" typeface="Times New Roman"/>
+        <a:font script="Thai" typeface="Angsana New"/>
+        <a:font script="Ethi" typeface="Nyala"/>
+        <a:font script="Beng" typeface="Vrinda"/>
+        <a:font script="Gujr" typeface="Shruti"/>
+        <a:font script="Khmr" typeface="MoolBoran"/>
+        <a:font script="Knda" typeface="Tunga"/>
+        <a:font script="Guru" typeface="Raavi"/>
+        <a:font script="Cans" typeface="Euphemia"/>
+        <a:font script="Cher" typeface="Plantagenet Cherokee"/>
+        <a:font script="Yiii" typeface="Microsoft Yi Baiti"/>
+        <a:font script="Tibt" typeface="Microsoft Himalaya"/>
+        <a:font script="Thaa" typeface="MV Boli"/>
+        <a:font script="Deva" typeface="Mangal"/>
+        <a:font script="Telu" typeface="Gautami"/>
+        <a:font script="Taml" typeface="Latha"/>
+        <a:font script="Syrc" typeface="Estrangelo Edessa"/>
+        <a:font script="Orya" typeface="Kalinga"/>
+        <a:font script="Mlym" typeface="Kartika"/>
+        <a:font script="Laoo" typeface="DokChampa"/>
+        <a:font script="Sinh" typeface="Iskoola Pota"/>
+        <a:font script="Mong" typeface="Mongolian Baiti"/>
+        <a:font script="Viet" typeface="Times New Roman"/>
+        <a:font script="Uigh" typeface="Microsoft Uighur"/>
+        <a:font script="Geor" typeface="Sylfaen"/>
+        <a:font script="Armn" typeface="Arial"/>
+        <a:font script="Bugi" typeface="Leelawadee UI"/>
+        <a:font script="Bopo" typeface="Microsoft JhengHei"/>
+        <a:font script="Java" typeface="Javanese Text"/>
+        <a:font script="Lisu" typeface="Segoe UI"/>
+        <a:font script="Mymr" typeface="Myanmar Text"/>
+        <a:font script="Nkoo" typeface="Ebrima"/>
+        <a:font script="Olck" typeface="Nirmala UI"/>
+        <a:font script="Osma" typeface="Ebrima"/>
+        <a:font script="Phag" typeface="Phagspa"/>
+        <a:font script="Syrn" typeface="Estrangelo Edessa"/>
+        <a:font script="Syrj" typeface="Estrangelo Edessa"/>
+        <a:font script="Syre" typeface="Estrangelo Edessa"/>
+        <a:font script="Sora" typeface="Nirmala UI"/>
+        <a:font script="Tale" typeface="Microsoft Tai Le"/>
+        <a:font script="Talu" typeface="Microsoft New Tai Lue"/>
+        <a:font script="Tfng" typeface="Ebrima"/>
+      </a:majorFont>
+      <a:minorFont>
+        <a:latin typeface="Aptos" panose="02110004020202020204"/>
+        <a:ea typeface=""/>
+        <a:cs typeface=""/>
+        <a:font script="Jpan" typeface="游ゴシック"/>
+        <a:font script="Hang" typeface="맑은 고딕"/>
+        <a:font script="Hans" typeface="等线"/>
+        <a:font script="Hant" typeface="新細明體"/>
+        <a:font script="Arab" typeface="Arial"/>
+        <a:font script="Hebr" typeface="Arial"/>
+        <a:font script="Thai" typeface="Cordia New"/>
+        <a:font script="Ethi" typeface="Nyala"/>
+        <a:font script="Beng" typeface="Vrinda"/>
+        <a:font script="Gujr" typeface="Shruti"/>
+        <a:font script="Khmr" typeface="DaunPenh"/>
+        <a:font script="Knda" typeface="Tunga"/>
+        <a:font script="Guru" typeface="Raavi"/>
+        <a:font script="Cans" typeface="Euphemia"/>
+        <a:font script="Cher" typeface="Plantagenet Cherokee"/>
+        <a:font script="Yiii" typeface="Microsoft Yi Baiti"/>
+        <a:font script="Tibt" typeface="Microsoft Himalaya"/>
+        <a:font script="Thaa" typeface="MV Boli"/>
+        <a:font script="Deva" typeface="Mangal"/>
+        <a:font script="Telu" typeface="Gautami"/>
+        <a:font script="Taml" typeface="Latha"/>
+        <a:font script="Syrc" typeface="Estrangelo Edessa"/>
+        <a:font script="Orya" typeface="Kalinga"/>
+        <a:font script="Mlym" typeface="Kartika"/>
+        <a:font script="Laoo" typeface="DokChampa"/>
+        <a:font script="Sinh" typeface="Iskoola Pota"/>
+        <a:font script="Mong" typeface="Mongolian Baiti"/>
+        <a:font script="Viet" typeface="Arial"/>
+        <a:font script="Uigh" typeface="Microsoft Uighur"/>
+        <a:font script="Geor" typeface="Sylfaen"/>
+        <a:font script="Armn" typeface="Arial"/>
+        <a:font script="Bugi" typeface="Leelawadee UI"/>
+        <a:font script="Bopo" typeface="Microsoft JhengHei"/>
+        <a:font script="Java" typeface="Javanese Text"/>
+        <a:font script="Lisu" typeface="Segoe UI"/>
+        <a:font script="Mymr" typeface="Myanmar Text"/>
+        <a:font script="Nkoo" typeface="Ebrima"/>
+        <a:font script="Olck" typeface="Nirmala UI"/>
+        <a:font script="Osma" typeface="Ebrima"/>
+        <a:font script="Phag" typeface="Phagspa"/>
+        <a:font script="Syrn" typeface="Estrangelo Edessa"/>
+        <a:font script="Syrj" typeface="Estrangelo Edessa"/>
+        <a:font script="Syre" typeface="Estrangelo Edessa"/>
+        <a:font script="Sora" typeface="Nirmala UI"/>
+        <a:font script="Tale" typeface="Microsoft Tai Le"/>
+        <a:font script="Talu" typeface="Microsoft New Tai Lue"/>
+        <a:font script="Tfng" typeface="Ebrima"/>
+      </a:minorFont>
+    </a:fontScheme>
+    <a:fmtScheme name="Office">
+      <a:fillStyleLst>
+        <a:solidFill>
+          <a:schemeClr val="phClr"/>
+        </a:solidFill>
+        <a:gradFill rotWithShape="1">
+          <a:gsLst>
+            <a:gs pos="0">
+              <a:schemeClr val="phClr">
+                <a:lumMod val="110000"/>
+                <a:satMod val="105000"/>
+                <a:tint val="67000"/>
+              </a:schemeClr>
+            </a:gs>
+            <a:gs pos="50000">
+              <a:schemeClr val="phClr">
+                <a:lumMod val="105000"/>
+                <a:satMod val="103000"/>
+                <a:tint val="73000"/>
+              </a:schemeClr>
+            </a:gs>
+            <a:gs pos="100000">
+              <a:schemeClr val="phClr">
+                <a:lumMod val="105000"/>
+                <a:satMod val="109000"/>
+                <a:tint val="81000"/>
+              </a:schemeClr>
+            </a:gs>
+          </a:gsLst>
+          <a:lin ang="5400000" scaled="0"/>
+        </a:gradFill>
+        <a:gradFill rotWithShape="1">
+          <a:gsLst>
+            <a:gs pos="0">
+              <a:schemeClr val="phClr">
+                <a:satMod val="103000"/>
+                <a:lumMod val="102000"/>
+                <a:tint val="94000"/>
+              </a:schemeClr>
+            </a:gs>
+            <a:gs pos="50000">
+              <a:schemeClr val="phClr">
+                <a:satMod val="110000"/>
+                <a:lumMod val="100000"/>
+                <a:shade val="100000"/>
+              </a:schemeClr>
+            </a:gs>
+            <a:gs pos="100000">
+              <a:schemeClr val="phClr">
+                <a:lumMod val="99000"/>
+                <a:satMod val="120000"/>
+                <a:shade val="78000"/>
+              </a:schemeClr>
+            </a:gs>
+          </a:gsLst>
+          <a:lin ang="5400000" scaled="0"/>
+        </a:gradFill>
+      </a:fillStyleLst>
+      <a:lnStyleLst>
+        <a:ln w="12700" cap="flat" cmpd="sng" algn="ctr">
+          <a:solidFill>
+            <a:schemeClr val="phClr"/>
+          </a:solidFill>
+          <a:prstDash val="solid"/>
+          <a:miter lim="800000"/>
+        </a:ln>
+        <a:ln w="19050" cap="flat" cmpd="sng" algn="ctr">
+          <a:solidFill>
+            <a:schemeClr val="phClr"/>
+          </a:solidFill>
+          <a:prstDash val="solid"/>
+          <a:miter lim="800000"/>
+        </a:ln>
+        <a:ln w="25400" cap="flat" cmpd="sng" algn="ctr">
+          <a:solidFill>
+            <a:schemeClr val="phClr"/>
+          </a:solidFill>
+          <a:prstDash val="solid"/>
+          <a:miter lim="800000"/>
+        </a:ln>
+      </a:lnStyleLst>
+      <a:effectStyleLst>
+        <a:effectStyle>
+          <a:effectLst/>
+        </a:effectStyle>
+        <a:effectStyle>
+          <a:effectLst/>
+        </a:effectStyle>
+        <a:effectStyle>
+          <a:effectLst>
+            <a:outerShdw blurRad="57150" dist="19050" dir="5400000" algn="ctr" rotWithShape="0">
+              <a:srgbClr val="000000">
+                <a:alpha val="63000"/>
+              </a:srgbClr>
+            </a:outerShdw>
+          </a:effectLst>
+        </a:effectStyle>
+      </a:effectStyleLst>
+      <a:bgFillStyleLst>
+        <a:solidFill>
+          <a:schemeClr val="phClr"/>
+        </a:solidFill>
+        <a:solidFill>
+          <a:schemeClr val="phClr">
+            <a:tint val="95000"/>
+            <a:satMod val="170000"/>
+          </a:schemeClr>
+        </a:solidFill>
+        <a:gradFill rotWithShape="1">
+          <a:gsLst>
+            <a:gs pos="0">
+              <a:schemeClr val="phClr">
+                <a:tint val="93000"/>
+                <a:satMod val="150000"/>
+                <a:shade val="98000"/>
+                <a:lumMod val="102000"/>
+              </a:schemeClr>
+            </a:gs>
+            <a:gs pos="50000">
+              <a:schemeClr val="phClr">
+                <a:tint val="98000"/>
+                <a:satMod val="130000"/>
+                <a:shade val="90000"/>
+                <a:lumMod val="103000"/>
+              </a:schemeClr>
+            </a:gs>
+            <a:gs pos="100000">
+              <a:schemeClr val="phClr">
+                <a:shade val="63000"/>
+                <a:satMod val="120000"/>
+              </a:schemeClr>
+            </a:gs>
+          </a:gsLst>
+          <a:lin ang="5400000" scaled="0"/>
+        </a:gradFill>
+      </a:bgFillStyleLst>
+    </a:fmtScheme>
+  </a:themeElements>
+  <a:objectDefaults>
+    <a:lnDef>
+      <a:spPr/>
+      <a:bodyPr/>
+      <a:lstStyle/>
+      <a:style>
+        <a:lnRef idx="2">
+          <a:schemeClr val="accent1"/>
+        </a:lnRef>
+        <a:fillRef idx="0">
+          <a:schemeClr val="accent1"/>
+        </a:fillRef>
+        <a:effectRef idx="1">
+          <a:schemeClr val="accent1"/>
+        </a:effectRef>
+        <a:fontRef idx="minor">
+          <a:schemeClr val="tx1"/>
+        </a:fontRef>
+      </a:style>
+    </a:lnDef>
+  </a:objectDefaults>
+  <a:extraClrSchemeLst/>
+  <a:extLst>
+    <a:ext uri="{05A4C25C-085E-4340-85A3-A5531E510DB2}">
+      <thm15:themeFamily xmlns:thm15="http://schemas.microsoft.com/office/thememl/2012/main" name="Office Theme" id="{2E142A2C-CD16-42D6-873A-C26D2A0506FA}" vid="{1BDDFF52-6CD6-40A5-AB3C-68EB2F1E4D0A}"/>
+    </a:ext>
+  </a:extLst>
+</a:theme>
 </file>
</xml_diff>